<commit_message>
v0.6.0: Tutorial slides + local Tutorial.pptx support
Tutorial.pptx: Added 8 new slides covering:
- BiomedPPTX Features overview
- SMART Browser: overview + how-to
- Pattern Brush: overview + how-to + tips
- Hue/Saturation Recolor guide
- Licensing & Attribution info

TutorialActionHandler: now opens local Tutorial.pptx from
AppData or add-in directory before falling back to the wiki URL.
No longer requires remote server download.

Co-Authored-By: Claude Opus 4.6 (1M context) <noreply@anthropic.com>
</commit_message>
<xml_diff>
--- a/doc/Tutorial.pptx
+++ b/doc/Tutorial.pptx
@@ -5,7 +5,7 @@
     <p:sldMasterId id="2147483648" r:id="rId1"/>
   </p:sldMasterIdLst>
   <p:notesMasterIdLst>
-    <p:notesMasterId r:id="rId69"/>
+    <p:notesMasterId r:id="rId77"/>
   </p:notesMasterIdLst>
   <p:sldIdLst>
     <p:sldId id="296" r:id="rId2"/>
@@ -75,6 +75,14 @@
     <p:sldId id="404" r:id="rId66"/>
     <p:sldId id="405" r:id="rId67"/>
     <p:sldId id="305" r:id="rId68"/>
+    <p:sldId id="439" r:id="rId69"/>
+    <p:sldId id="440" r:id="rId70"/>
+    <p:sldId id="441" r:id="rId71"/>
+    <p:sldId id="442" r:id="rId72"/>
+    <p:sldId id="443" r:id="rId73"/>
+    <p:sldId id="444" r:id="rId74"/>
+    <p:sldId id="445" r:id="rId75"/>
+    <p:sldId id="446" r:id="rId76"/>
   </p:sldIdLst>
   <p:sldSz cx="9144000" cy="6858000" type="screen4x3"/>
   <p:notesSz cx="6858000" cy="9144000"/>
@@ -317,6 +325,14 @@
         <p14:section name="Wrap up" id="{5BBA1A93-B239-4917-BAC7-9CBE7A60C0BF}">
           <p14:sldIdLst>
             <p14:sldId id="305"/>
+            <p14:sldId id="439"/>
+            <p14:sldId id="440"/>
+            <p14:sldId id="441"/>
+            <p14:sldId id="442"/>
+            <p14:sldId id="443"/>
+            <p14:sldId id="444"/>
+            <p14:sldId id="445"/>
+            <p14:sldId id="446"/>
           </p14:sldIdLst>
         </p14:section>
       </p14:sectionLst>
@@ -488,7 +504,7 @@
           <a:p>
             <a:fld id="{3E86CC0F-BBF3-4E07-94E0-0549B7D560A9}" type="datetimeFigureOut">
               <a:rPr lang="en-SG" smtClean="0"/>
-              <a:t>15/4/2019</a:t>
+              <a:t>29/9/2026</a:t>
             </a:fld>
             <a:endParaRPr lang="en-SG"/>
           </a:p>
@@ -3105,7 +3121,7 @@
             <a:fld id="{1D8BD707-D9CF-40AE-B4C6-C98DA3205C09}" type="datetimeFigureOut">
               <a:rPr lang="en-US" smtClean="0"/>
               <a:pPr/>
-              <a:t>4/15/2019</a:t>
+              <a:t>9/29/2026</a:t>
             </a:fld>
             <a:endParaRPr lang="en-US"/>
           </a:p>
@@ -3270,7 +3286,7 @@
             <a:fld id="{1D8BD707-D9CF-40AE-B4C6-C98DA3205C09}" type="datetimeFigureOut">
               <a:rPr lang="en-US" smtClean="0"/>
               <a:pPr/>
-              <a:t>4/15/2019</a:t>
+              <a:t>9/29/2026</a:t>
             </a:fld>
             <a:endParaRPr lang="en-US"/>
           </a:p>
@@ -3445,7 +3461,7 @@
             <a:fld id="{1D8BD707-D9CF-40AE-B4C6-C98DA3205C09}" type="datetimeFigureOut">
               <a:rPr lang="en-US" smtClean="0"/>
               <a:pPr/>
-              <a:t>4/15/2019</a:t>
+              <a:t>9/29/2026</a:t>
             </a:fld>
             <a:endParaRPr lang="en-US"/>
           </a:p>
@@ -3612,7 +3628,7 @@
             <a:fld id="{1D8BD707-D9CF-40AE-B4C6-C98DA3205C09}" type="datetimeFigureOut">
               <a:rPr lang="en-US" smtClean="0"/>
               <a:pPr/>
-              <a:t>4/15/2019</a:t>
+              <a:t>9/29/2026</a:t>
             </a:fld>
             <a:endParaRPr lang="en-US"/>
           </a:p>
@@ -3782,7 +3798,7 @@
             <a:fld id="{1D8BD707-D9CF-40AE-B4C6-C98DA3205C09}" type="datetimeFigureOut">
               <a:rPr lang="en-US" smtClean="0"/>
               <a:pPr/>
-              <a:t>4/15/2019</a:t>
+              <a:t>9/29/2026</a:t>
             </a:fld>
             <a:endParaRPr lang="en-US"/>
           </a:p>
@@ -4024,7 +4040,7 @@
             <a:fld id="{1D8BD707-D9CF-40AE-B4C6-C98DA3205C09}" type="datetimeFigureOut">
               <a:rPr lang="en-US" smtClean="0"/>
               <a:pPr/>
-              <a:t>4/15/2019</a:t>
+              <a:t>9/29/2026</a:t>
             </a:fld>
             <a:endParaRPr lang="en-US"/>
           </a:p>
@@ -4306,7 +4322,7 @@
             <a:fld id="{1D8BD707-D9CF-40AE-B4C6-C98DA3205C09}" type="datetimeFigureOut">
               <a:rPr lang="en-US" smtClean="0"/>
               <a:pPr/>
-              <a:t>4/15/2019</a:t>
+              <a:t>9/29/2026</a:t>
             </a:fld>
             <a:endParaRPr lang="en-US"/>
           </a:p>
@@ -4722,7 +4738,7 @@
             <a:fld id="{1D8BD707-D9CF-40AE-B4C6-C98DA3205C09}" type="datetimeFigureOut">
               <a:rPr lang="en-US" smtClean="0"/>
               <a:pPr/>
-              <a:t>4/15/2019</a:t>
+              <a:t>9/29/2026</a:t>
             </a:fld>
             <a:endParaRPr lang="en-US"/>
           </a:p>
@@ -4836,7 +4852,7 @@
             <a:fld id="{1D8BD707-D9CF-40AE-B4C6-C98DA3205C09}" type="datetimeFigureOut">
               <a:rPr lang="en-US" smtClean="0"/>
               <a:pPr/>
-              <a:t>4/15/2019</a:t>
+              <a:t>9/29/2026</a:t>
             </a:fld>
             <a:endParaRPr lang="en-US"/>
           </a:p>
@@ -4928,7 +4944,7 @@
             <a:fld id="{1D8BD707-D9CF-40AE-B4C6-C98DA3205C09}" type="datetimeFigureOut">
               <a:rPr lang="en-US" smtClean="0"/>
               <a:pPr/>
-              <a:t>4/15/2019</a:t>
+              <a:t>9/29/2026</a:t>
             </a:fld>
             <a:endParaRPr lang="en-US"/>
           </a:p>
@@ -5200,7 +5216,7 @@
             <a:fld id="{1D8BD707-D9CF-40AE-B4C6-C98DA3205C09}" type="datetimeFigureOut">
               <a:rPr lang="en-US" smtClean="0"/>
               <a:pPr/>
-              <a:t>4/15/2019</a:t>
+              <a:t>9/29/2026</a:t>
             </a:fld>
             <a:endParaRPr lang="en-US"/>
           </a:p>
@@ -5449,7 +5465,7 @@
             <a:fld id="{1D8BD707-D9CF-40AE-B4C6-C98DA3205C09}" type="datetimeFigureOut">
               <a:rPr lang="en-US" smtClean="0"/>
               <a:pPr/>
-              <a:t>4/15/2019</a:t>
+              <a:t>9/29/2026</a:t>
             </a:fld>
             <a:endParaRPr lang="en-US"/>
           </a:p>
@@ -5657,7 +5673,7 @@
             <a:fld id="{1D8BD707-D9CF-40AE-B4C6-C98DA3205C09}" type="datetimeFigureOut">
               <a:rPr lang="en-US" smtClean="0"/>
               <a:pPr/>
-              <a:t>4/15/2019</a:t>
+              <a:t>9/29/2026</a:t>
             </a:fld>
             <a:endParaRPr lang="en-US"/>
           </a:p>
@@ -6307,7 +6323,7 @@
           <p:cNvPr id="16" name="Group 15">
             <a:extLst>
               <a:ext uri="{FF2B5EF4-FFF2-40B4-BE49-F238E27FC236}">
-                <a16:creationId xmlns:a16="http://schemas.microsoft.com/office/drawing/2014/main" xmlns="" id="{11860AEE-009E-4CA9-A239-1513861866EA}"/>
+                <a16:creationId xmlns:a16="http://schemas.microsoft.com/office/drawing/2014/main" id="{11860AEE-009E-4CA9-A239-1513861866EA}"/>
               </a:ext>
             </a:extLst>
           </p:cNvPr>
@@ -6329,7 +6345,7 @@
             <p:cNvPr id="17" name="Flowchart: Connector 16">
               <a:extLst>
                 <a:ext uri="{FF2B5EF4-FFF2-40B4-BE49-F238E27FC236}">
-                  <a16:creationId xmlns:a16="http://schemas.microsoft.com/office/drawing/2014/main" xmlns="" id="{215DA532-B42A-440C-A554-F80F16379160}"/>
+                  <a16:creationId xmlns:a16="http://schemas.microsoft.com/office/drawing/2014/main" id="{215DA532-B42A-440C-A554-F80F16379160}"/>
                 </a:ext>
               </a:extLst>
             </p:cNvPr>
@@ -6383,7 +6399,7 @@
             <p:cNvPr id="18" name="Rectangular Callout 6">
               <a:extLst>
                 <a:ext uri="{FF2B5EF4-FFF2-40B4-BE49-F238E27FC236}">
-                  <a16:creationId xmlns:a16="http://schemas.microsoft.com/office/drawing/2014/main" xmlns="" id="{2F74D3D8-22E4-4409-A3A7-A4C3D796B975}"/>
+                  <a16:creationId xmlns:a16="http://schemas.microsoft.com/office/drawing/2014/main" id="{2F74D3D8-22E4-4409-A3A7-A4C3D796B975}"/>
                 </a:ext>
               </a:extLst>
             </p:cNvPr>
@@ -6684,7 +6700,7 @@
           <p:cNvPr id="5" name="Picture 4">
             <a:extLst>
               <a:ext uri="{FF2B5EF4-FFF2-40B4-BE49-F238E27FC236}">
-                <a16:creationId xmlns:a16="http://schemas.microsoft.com/office/drawing/2014/main" xmlns="" id="{18A45EEB-9755-4A12-8204-84E8DAADE6C0}"/>
+                <a16:creationId xmlns:a16="http://schemas.microsoft.com/office/drawing/2014/main" id="{18A45EEB-9755-4A12-8204-84E8DAADE6C0}"/>
               </a:ext>
             </a:extLst>
           </p:cNvPr>
@@ -6847,7 +6863,7 @@
           <p:cNvPr id="2" name="Group 1">
             <a:extLst>
               <a:ext uri="{FF2B5EF4-FFF2-40B4-BE49-F238E27FC236}">
-                <a16:creationId xmlns:a16="http://schemas.microsoft.com/office/drawing/2014/main" xmlns="" id="{290B12D9-F24A-4ED1-9B73-D0D4B3D588F7}"/>
+                <a16:creationId xmlns:a16="http://schemas.microsoft.com/office/drawing/2014/main" id="{290B12D9-F24A-4ED1-9B73-D0D4B3D588F7}"/>
               </a:ext>
             </a:extLst>
           </p:cNvPr>
@@ -6867,7 +6883,7 @@
             <p:cNvPr id="10" name="Freeform: Shape 9">
               <a:extLst>
                 <a:ext uri="{FF2B5EF4-FFF2-40B4-BE49-F238E27FC236}">
-                  <a16:creationId xmlns:a16="http://schemas.microsoft.com/office/drawing/2014/main" xmlns="" id="{AC0ED157-CBF6-495E-842F-C92CD6757F03}"/>
+                  <a16:creationId xmlns:a16="http://schemas.microsoft.com/office/drawing/2014/main" id="{AC0ED157-CBF6-495E-842F-C92CD6757F03}"/>
                 </a:ext>
               </a:extLst>
             </p:cNvPr>
@@ -7005,7 +7021,7 @@
             <p:cNvPr id="11" name="Rectangle 10">
               <a:extLst>
                 <a:ext uri="{FF2B5EF4-FFF2-40B4-BE49-F238E27FC236}">
-                  <a16:creationId xmlns:a16="http://schemas.microsoft.com/office/drawing/2014/main" xmlns="" id="{9B82F3F3-4CF7-4A93-8EE8-E15392AEEB66}"/>
+                  <a16:creationId xmlns:a16="http://schemas.microsoft.com/office/drawing/2014/main" id="{9B82F3F3-4CF7-4A93-8EE8-E15392AEEB66}"/>
                 </a:ext>
               </a:extLst>
             </p:cNvPr>
@@ -7058,7 +7074,7 @@
             <p:cNvPr id="12" name="Group 11">
               <a:extLst>
                 <a:ext uri="{FF2B5EF4-FFF2-40B4-BE49-F238E27FC236}">
-                  <a16:creationId xmlns:a16="http://schemas.microsoft.com/office/drawing/2014/main" xmlns="" id="{4C5C79A5-5106-46B3-8B89-17AF6362E555}"/>
+                  <a16:creationId xmlns:a16="http://schemas.microsoft.com/office/drawing/2014/main" id="{4C5C79A5-5106-46B3-8B89-17AF6362E555}"/>
                 </a:ext>
               </a:extLst>
             </p:cNvPr>
@@ -7078,7 +7094,7 @@
               <p:cNvPr id="13" name="Rectangle 12">
                 <a:extLst>
                   <a:ext uri="{FF2B5EF4-FFF2-40B4-BE49-F238E27FC236}">
-                    <a16:creationId xmlns:a16="http://schemas.microsoft.com/office/drawing/2014/main" xmlns="" id="{EE828773-E2EF-4BA7-AC59-9F4141AA1002}"/>
+                    <a16:creationId xmlns:a16="http://schemas.microsoft.com/office/drawing/2014/main" id="{EE828773-E2EF-4BA7-AC59-9F4141AA1002}"/>
                   </a:ext>
                 </a:extLst>
               </p:cNvPr>
@@ -7128,7 +7144,7 @@
               <p:cNvPr id="14" name="Rectangle 4">
                 <a:extLst>
                   <a:ext uri="{FF2B5EF4-FFF2-40B4-BE49-F238E27FC236}">
-                    <a16:creationId xmlns:a16="http://schemas.microsoft.com/office/drawing/2014/main" xmlns="" id="{D93C2A59-BF32-4F86-95D4-D79FB9B5EAB8}"/>
+                    <a16:creationId xmlns:a16="http://schemas.microsoft.com/office/drawing/2014/main" id="{D93C2A59-BF32-4F86-95D4-D79FB9B5EAB8}"/>
                   </a:ext>
                 </a:extLst>
               </p:cNvPr>
@@ -7228,7 +7244,7 @@
             <p:cNvPr id="15" name="Freeform: Shape 14">
               <a:extLst>
                 <a:ext uri="{FF2B5EF4-FFF2-40B4-BE49-F238E27FC236}">
-                  <a16:creationId xmlns:a16="http://schemas.microsoft.com/office/drawing/2014/main" xmlns="" id="{0256924A-CDD9-486A-9BFD-ECFAC590B9B0}"/>
+                  <a16:creationId xmlns:a16="http://schemas.microsoft.com/office/drawing/2014/main" id="{0256924A-CDD9-486A-9BFD-ECFAC590B9B0}"/>
                 </a:ext>
               </a:extLst>
             </p:cNvPr>
@@ -11031,7 +11047,7 @@
           <p:cNvPr id="2" name="TextBox 3">
             <a:extLst>
               <a:ext uri="{FF2B5EF4-FFF2-40B4-BE49-F238E27FC236}">
-                <a16:creationId xmlns:a16="http://schemas.microsoft.com/office/drawing/2014/main" xmlns="" id="{1EDF233D-7DF3-4206-A542-B0F1E7EDA11F}"/>
+                <a16:creationId xmlns:a16="http://schemas.microsoft.com/office/drawing/2014/main" id="{1EDF233D-7DF3-4206-A542-B0F1E7EDA11F}"/>
               </a:ext>
             </a:extLst>
           </p:cNvPr>
@@ -11085,7 +11101,7 @@
           <p:cNvPr id="14" name="Picture 13">
             <a:extLst>
               <a:ext uri="{FF2B5EF4-FFF2-40B4-BE49-F238E27FC236}">
-                <a16:creationId xmlns:a16="http://schemas.microsoft.com/office/drawing/2014/main" xmlns="" id="{BA9B9AA3-AB93-4936-80D0-D91360A37CBD}"/>
+                <a16:creationId xmlns:a16="http://schemas.microsoft.com/office/drawing/2014/main" id="{BA9B9AA3-AB93-4936-80D0-D91360A37CBD}"/>
               </a:ext>
             </a:extLst>
           </p:cNvPr>
@@ -11151,7 +11167,7 @@
           <p:cNvPr id="3" name="TextBox 6">
             <a:extLst>
               <a:ext uri="{FF2B5EF4-FFF2-40B4-BE49-F238E27FC236}">
-                <a16:creationId xmlns:a16="http://schemas.microsoft.com/office/drawing/2014/main" xmlns="" id="{28EF15CF-4B99-4548-932A-49AC6119A62B}"/>
+                <a16:creationId xmlns:a16="http://schemas.microsoft.com/office/drawing/2014/main" id="{28EF15CF-4B99-4548-932A-49AC6119A62B}"/>
               </a:ext>
             </a:extLst>
           </p:cNvPr>
@@ -11233,7 +11249,7 @@
           <p:cNvPr id="12" name="Picture 11" descr="A screenshot of a cell phone&#10;&#10;Description generated with very high confidence">
             <a:extLst>
               <a:ext uri="{FF2B5EF4-FFF2-40B4-BE49-F238E27FC236}">
-                <a16:creationId xmlns:a16="http://schemas.microsoft.com/office/drawing/2014/main" xmlns="" id="{482C919E-7955-43FB-B7D2-2D9145710331}"/>
+                <a16:creationId xmlns:a16="http://schemas.microsoft.com/office/drawing/2014/main" id="{482C919E-7955-43FB-B7D2-2D9145710331}"/>
               </a:ext>
             </a:extLst>
           </p:cNvPr>
@@ -11269,7 +11285,7 @@
           <p:cNvPr id="14" name="Picture 13" descr="A close up of a logo&#10;&#10;Description generated with very high confidence">
             <a:extLst>
               <a:ext uri="{FF2B5EF4-FFF2-40B4-BE49-F238E27FC236}">
-                <a16:creationId xmlns:a16="http://schemas.microsoft.com/office/drawing/2014/main" xmlns="" id="{36D856B9-53C6-49EE-86F1-D1385F062749}"/>
+                <a16:creationId xmlns:a16="http://schemas.microsoft.com/office/drawing/2014/main" id="{36D856B9-53C6-49EE-86F1-D1385F062749}"/>
               </a:ext>
             </a:extLst>
           </p:cNvPr>
@@ -11305,7 +11321,7 @@
           <p:cNvPr id="16" name="Picture 15" descr="A close up of a sign&#10;&#10;Description generated with very high confidence">
             <a:extLst>
               <a:ext uri="{FF2B5EF4-FFF2-40B4-BE49-F238E27FC236}">
-                <a16:creationId xmlns:a16="http://schemas.microsoft.com/office/drawing/2014/main" xmlns="" id="{6CD10837-243C-4A19-856A-30B9B9AAC281}"/>
+                <a16:creationId xmlns:a16="http://schemas.microsoft.com/office/drawing/2014/main" id="{6CD10837-243C-4A19-856A-30B9B9AAC281}"/>
               </a:ext>
             </a:extLst>
           </p:cNvPr>
@@ -11341,7 +11357,7 @@
           <p:cNvPr id="17" name="TextBox 6">
             <a:extLst>
               <a:ext uri="{FF2B5EF4-FFF2-40B4-BE49-F238E27FC236}">
-                <a16:creationId xmlns:a16="http://schemas.microsoft.com/office/drawing/2014/main" xmlns="" id="{A5E16012-8701-422C-9FDA-636751D1F280}"/>
+                <a16:creationId xmlns:a16="http://schemas.microsoft.com/office/drawing/2014/main" id="{A5E16012-8701-422C-9FDA-636751D1F280}"/>
               </a:ext>
             </a:extLst>
           </p:cNvPr>
@@ -11402,7 +11418,7 @@
           <p:cNvPr id="19" name="Picture 18" descr="A screenshot of a cell phone&#10;&#10;Description generated with very high confidence">
             <a:extLst>
               <a:ext uri="{FF2B5EF4-FFF2-40B4-BE49-F238E27FC236}">
-                <a16:creationId xmlns:a16="http://schemas.microsoft.com/office/drawing/2014/main" xmlns="" id="{716E9F78-71C1-4EA7-97F7-509C5531F4B2}"/>
+                <a16:creationId xmlns:a16="http://schemas.microsoft.com/office/drawing/2014/main" id="{716E9F78-71C1-4EA7-97F7-509C5531F4B2}"/>
               </a:ext>
             </a:extLst>
           </p:cNvPr>
@@ -11438,7 +11454,7 @@
           <p:cNvPr id="20" name="TextBox 6">
             <a:extLst>
               <a:ext uri="{FF2B5EF4-FFF2-40B4-BE49-F238E27FC236}">
-                <a16:creationId xmlns:a16="http://schemas.microsoft.com/office/drawing/2014/main" xmlns="" id="{EBC89741-DB08-46D6-AF62-386920FFD7C0}"/>
+                <a16:creationId xmlns:a16="http://schemas.microsoft.com/office/drawing/2014/main" id="{EBC89741-DB08-46D6-AF62-386920FFD7C0}"/>
               </a:ext>
             </a:extLst>
           </p:cNvPr>
@@ -11499,7 +11515,7 @@
           <p:cNvPr id="22" name="Picture 21">
             <a:extLst>
               <a:ext uri="{FF2B5EF4-FFF2-40B4-BE49-F238E27FC236}">
-                <a16:creationId xmlns:a16="http://schemas.microsoft.com/office/drawing/2014/main" xmlns="" id="{66B2D33B-F503-4958-914A-78E9DB8F4B27}"/>
+                <a16:creationId xmlns:a16="http://schemas.microsoft.com/office/drawing/2014/main" id="{66B2D33B-F503-4958-914A-78E9DB8F4B27}"/>
               </a:ext>
             </a:extLst>
           </p:cNvPr>
@@ -11535,7 +11551,7 @@
           <p:cNvPr id="23" name="TextBox 6">
             <a:extLst>
               <a:ext uri="{FF2B5EF4-FFF2-40B4-BE49-F238E27FC236}">
-                <a16:creationId xmlns:a16="http://schemas.microsoft.com/office/drawing/2014/main" xmlns="" id="{F1EB1432-2517-40DC-85C1-6509E67E5E38}"/>
+                <a16:creationId xmlns:a16="http://schemas.microsoft.com/office/drawing/2014/main" id="{F1EB1432-2517-40DC-85C1-6509E67E5E38}"/>
               </a:ext>
             </a:extLst>
           </p:cNvPr>
@@ -11614,7 +11630,7 @@
           <p:cNvPr id="4" name="Picture 3" descr="A close up of a logo&#10;&#10;Description generated with very high confidence">
             <a:extLst>
               <a:ext uri="{FF2B5EF4-FFF2-40B4-BE49-F238E27FC236}">
-                <a16:creationId xmlns:a16="http://schemas.microsoft.com/office/drawing/2014/main" xmlns="" id="{4E76A9BA-A5D8-471A-B46B-460BF5D2A256}"/>
+                <a16:creationId xmlns:a16="http://schemas.microsoft.com/office/drawing/2014/main" id="{4E76A9BA-A5D8-471A-B46B-460BF5D2A256}"/>
               </a:ext>
             </a:extLst>
           </p:cNvPr>
@@ -11650,7 +11666,7 @@
           <p:cNvPr id="6" name="Picture 5" descr="A close up of a logo&#10;&#10;Description generated with very high confidence">
             <a:extLst>
               <a:ext uri="{FF2B5EF4-FFF2-40B4-BE49-F238E27FC236}">
-                <a16:creationId xmlns:a16="http://schemas.microsoft.com/office/drawing/2014/main" xmlns="" id="{7475179C-7095-4E7C-B924-F6F08E0F3C4B}"/>
+                <a16:creationId xmlns:a16="http://schemas.microsoft.com/office/drawing/2014/main" id="{7475179C-7095-4E7C-B924-F6F08E0F3C4B}"/>
               </a:ext>
             </a:extLst>
           </p:cNvPr>
@@ -11686,7 +11702,7 @@
           <p:cNvPr id="8" name="Picture 7">
             <a:extLst>
               <a:ext uri="{FF2B5EF4-FFF2-40B4-BE49-F238E27FC236}">
-                <a16:creationId xmlns:a16="http://schemas.microsoft.com/office/drawing/2014/main" xmlns="" id="{9B9CAB5C-8477-40E4-9FE4-13D0F4DE621D}"/>
+                <a16:creationId xmlns:a16="http://schemas.microsoft.com/office/drawing/2014/main" id="{9B9CAB5C-8477-40E4-9FE4-13D0F4DE621D}"/>
               </a:ext>
             </a:extLst>
           </p:cNvPr>
@@ -11752,7 +11768,7 @@
           <p:cNvPr id="3" name="Group 2">
             <a:extLst>
               <a:ext uri="{FF2B5EF4-FFF2-40B4-BE49-F238E27FC236}">
-                <a16:creationId xmlns:a16="http://schemas.microsoft.com/office/drawing/2014/main" xmlns="" id="{2D2E751F-191B-4F38-9B1A-4C3097FB28A9}"/>
+                <a16:creationId xmlns:a16="http://schemas.microsoft.com/office/drawing/2014/main" id="{2D2E751F-191B-4F38-9B1A-4C3097FB28A9}"/>
               </a:ext>
             </a:extLst>
           </p:cNvPr>
@@ -11772,7 +11788,7 @@
             <p:cNvPr id="6" name="Group 5">
               <a:extLst>
                 <a:ext uri="{FF2B5EF4-FFF2-40B4-BE49-F238E27FC236}">
-                  <a16:creationId xmlns:a16="http://schemas.microsoft.com/office/drawing/2014/main" xmlns="" id="{40B1E097-408F-4199-8639-828701A1AB67}"/>
+                  <a16:creationId xmlns:a16="http://schemas.microsoft.com/office/drawing/2014/main" id="{40B1E097-408F-4199-8639-828701A1AB67}"/>
                 </a:ext>
               </a:extLst>
             </p:cNvPr>
@@ -11792,7 +11808,7 @@
               <p:cNvPr id="8" name="Rectangle 7">
                 <a:extLst>
                   <a:ext uri="{FF2B5EF4-FFF2-40B4-BE49-F238E27FC236}">
-                    <a16:creationId xmlns:a16="http://schemas.microsoft.com/office/drawing/2014/main" xmlns="" id="{F6F85F25-C495-402B-AA53-B7A872A05EC1}"/>
+                    <a16:creationId xmlns:a16="http://schemas.microsoft.com/office/drawing/2014/main" id="{F6F85F25-C495-402B-AA53-B7A872A05EC1}"/>
                   </a:ext>
                 </a:extLst>
               </p:cNvPr>
@@ -11842,7 +11858,7 @@
               <p:cNvPr id="9" name="Rectangle 4">
                 <a:extLst>
                   <a:ext uri="{FF2B5EF4-FFF2-40B4-BE49-F238E27FC236}">
-                    <a16:creationId xmlns:a16="http://schemas.microsoft.com/office/drawing/2014/main" xmlns="" id="{11E827C1-A4E1-4DAE-8174-ECA5FCCF088D}"/>
+                    <a16:creationId xmlns:a16="http://schemas.microsoft.com/office/drawing/2014/main" id="{11E827C1-A4E1-4DAE-8174-ECA5FCCF088D}"/>
                   </a:ext>
                 </a:extLst>
               </p:cNvPr>
@@ -11942,7 +11958,7 @@
             <p:cNvPr id="10" name="Rectangle: Rounded Corners 9">
               <a:extLst>
                 <a:ext uri="{FF2B5EF4-FFF2-40B4-BE49-F238E27FC236}">
-                  <a16:creationId xmlns:a16="http://schemas.microsoft.com/office/drawing/2014/main" xmlns="" id="{C4B7736D-3571-4E03-AF04-FF3C22F8ECA5}"/>
+                  <a16:creationId xmlns:a16="http://schemas.microsoft.com/office/drawing/2014/main" id="{C4B7736D-3571-4E03-AF04-FF3C22F8ECA5}"/>
                 </a:ext>
               </a:extLst>
             </p:cNvPr>
@@ -11996,7 +12012,7 @@
             <p:cNvPr id="11" name="Rectangle: Rounded Corners 10">
               <a:extLst>
                 <a:ext uri="{FF2B5EF4-FFF2-40B4-BE49-F238E27FC236}">
-                  <a16:creationId xmlns:a16="http://schemas.microsoft.com/office/drawing/2014/main" xmlns="" id="{3AFFF92D-2342-41E5-81FC-7C3EC1712801}"/>
+                  <a16:creationId xmlns:a16="http://schemas.microsoft.com/office/drawing/2014/main" id="{3AFFF92D-2342-41E5-81FC-7C3EC1712801}"/>
                 </a:ext>
               </a:extLst>
             </p:cNvPr>
@@ -12050,7 +12066,7 @@
             <p:cNvPr id="12" name="Rectangle: Rounded Corners 11">
               <a:extLst>
                 <a:ext uri="{FF2B5EF4-FFF2-40B4-BE49-F238E27FC236}">
-                  <a16:creationId xmlns:a16="http://schemas.microsoft.com/office/drawing/2014/main" xmlns="" id="{7639A589-8BD6-4C9C-9288-F59C3FDC7F08}"/>
+                  <a16:creationId xmlns:a16="http://schemas.microsoft.com/office/drawing/2014/main" id="{7639A589-8BD6-4C9C-9288-F59C3FDC7F08}"/>
                 </a:ext>
               </a:extLst>
             </p:cNvPr>
@@ -12104,7 +12120,7 @@
             <p:cNvPr id="13" name="Rectangle: Rounded Corners 12">
               <a:extLst>
                 <a:ext uri="{FF2B5EF4-FFF2-40B4-BE49-F238E27FC236}">
-                  <a16:creationId xmlns:a16="http://schemas.microsoft.com/office/drawing/2014/main" xmlns="" id="{ACF67E40-A312-4D7A-ABB7-A997DE4C2361}"/>
+                  <a16:creationId xmlns:a16="http://schemas.microsoft.com/office/drawing/2014/main" id="{ACF67E40-A312-4D7A-ABB7-A997DE4C2361}"/>
                 </a:ext>
               </a:extLst>
             </p:cNvPr>
@@ -12158,7 +12174,7 @@
             <p:cNvPr id="14" name="Freeform: Shape 13">
               <a:extLst>
                 <a:ext uri="{FF2B5EF4-FFF2-40B4-BE49-F238E27FC236}">
-                  <a16:creationId xmlns:a16="http://schemas.microsoft.com/office/drawing/2014/main" xmlns="" id="{B1402143-801A-4082-9B09-F9B51CDB0444}"/>
+                  <a16:creationId xmlns:a16="http://schemas.microsoft.com/office/drawing/2014/main" id="{B1402143-801A-4082-9B09-F9B51CDB0444}"/>
                 </a:ext>
               </a:extLst>
             </p:cNvPr>
@@ -12396,7 +12412,7 @@
           <p:cNvPr id="16" name="Group 15">
             <a:extLst>
               <a:ext uri="{FF2B5EF4-FFF2-40B4-BE49-F238E27FC236}">
-                <a16:creationId xmlns:a16="http://schemas.microsoft.com/office/drawing/2014/main" xmlns="" id="{9BAFDAD4-9618-43A0-B172-AFA924B8AF7A}"/>
+                <a16:creationId xmlns:a16="http://schemas.microsoft.com/office/drawing/2014/main" id="{9BAFDAD4-9618-43A0-B172-AFA924B8AF7A}"/>
               </a:ext>
             </a:extLst>
           </p:cNvPr>
@@ -12416,7 +12432,7 @@
             <p:cNvPr id="17" name="Group 16">
               <a:extLst>
                 <a:ext uri="{FF2B5EF4-FFF2-40B4-BE49-F238E27FC236}">
-                  <a16:creationId xmlns:a16="http://schemas.microsoft.com/office/drawing/2014/main" xmlns="" id="{1CF14FC6-BE42-4CD2-A1B9-0B5AF2E2EB40}"/>
+                  <a16:creationId xmlns:a16="http://schemas.microsoft.com/office/drawing/2014/main" id="{1CF14FC6-BE42-4CD2-A1B9-0B5AF2E2EB40}"/>
                 </a:ext>
               </a:extLst>
             </p:cNvPr>
@@ -12436,7 +12452,7 @@
               <p:cNvPr id="22" name="Rectangle 21">
                 <a:extLst>
                   <a:ext uri="{FF2B5EF4-FFF2-40B4-BE49-F238E27FC236}">
-                    <a16:creationId xmlns:a16="http://schemas.microsoft.com/office/drawing/2014/main" xmlns="" id="{58AE2CF4-128C-4103-A912-57E35775851D}"/>
+                    <a16:creationId xmlns:a16="http://schemas.microsoft.com/office/drawing/2014/main" id="{58AE2CF4-128C-4103-A912-57E35775851D}"/>
                   </a:ext>
                 </a:extLst>
               </p:cNvPr>
@@ -12486,7 +12502,7 @@
               <p:cNvPr id="23" name="Rectangle 4">
                 <a:extLst>
                   <a:ext uri="{FF2B5EF4-FFF2-40B4-BE49-F238E27FC236}">
-                    <a16:creationId xmlns:a16="http://schemas.microsoft.com/office/drawing/2014/main" xmlns="" id="{D7530CAC-5A24-470F-BFCF-8B9601EB74AF}"/>
+                    <a16:creationId xmlns:a16="http://schemas.microsoft.com/office/drawing/2014/main" id="{D7530CAC-5A24-470F-BFCF-8B9601EB74AF}"/>
                   </a:ext>
                 </a:extLst>
               </p:cNvPr>
@@ -12586,7 +12602,7 @@
             <p:cNvPr id="18" name="Freeform: Shape 17">
               <a:extLst>
                 <a:ext uri="{FF2B5EF4-FFF2-40B4-BE49-F238E27FC236}">
-                  <a16:creationId xmlns:a16="http://schemas.microsoft.com/office/drawing/2014/main" xmlns="" id="{35E6372C-3A7A-479F-91AE-5B6763C5F628}"/>
+                  <a16:creationId xmlns:a16="http://schemas.microsoft.com/office/drawing/2014/main" id="{35E6372C-3A7A-479F-91AE-5B6763C5F628}"/>
                 </a:ext>
               </a:extLst>
             </p:cNvPr>
@@ -12718,7 +12734,7 @@
             <p:cNvPr id="19" name="Rectangle: Rounded Corners 18">
               <a:extLst>
                 <a:ext uri="{FF2B5EF4-FFF2-40B4-BE49-F238E27FC236}">
-                  <a16:creationId xmlns:a16="http://schemas.microsoft.com/office/drawing/2014/main" xmlns="" id="{7C3B9DB6-6799-4B90-A718-F7465EB68483}"/>
+                  <a16:creationId xmlns:a16="http://schemas.microsoft.com/office/drawing/2014/main" id="{7C3B9DB6-6799-4B90-A718-F7465EB68483}"/>
                 </a:ext>
               </a:extLst>
             </p:cNvPr>
@@ -12772,7 +12788,7 @@
             <p:cNvPr id="20" name="Rectangle: Rounded Corners 19">
               <a:extLst>
                 <a:ext uri="{FF2B5EF4-FFF2-40B4-BE49-F238E27FC236}">
-                  <a16:creationId xmlns:a16="http://schemas.microsoft.com/office/drawing/2014/main" xmlns="" id="{1EFC1558-819D-421B-9CAB-2EE1C08B9ED7}"/>
+                  <a16:creationId xmlns:a16="http://schemas.microsoft.com/office/drawing/2014/main" id="{1EFC1558-819D-421B-9CAB-2EE1C08B9ED7}"/>
                 </a:ext>
               </a:extLst>
             </p:cNvPr>
@@ -12826,7 +12842,7 @@
             <p:cNvPr id="21" name="Rectangle: Rounded Corners 20">
               <a:extLst>
                 <a:ext uri="{FF2B5EF4-FFF2-40B4-BE49-F238E27FC236}">
-                  <a16:creationId xmlns:a16="http://schemas.microsoft.com/office/drawing/2014/main" xmlns="" id="{3D4C057E-4075-4E98-A39F-940D45CFF0B7}"/>
+                  <a16:creationId xmlns:a16="http://schemas.microsoft.com/office/drawing/2014/main" id="{3D4C057E-4075-4E98-A39F-940D45CFF0B7}"/>
                 </a:ext>
               </a:extLst>
             </p:cNvPr>
@@ -13244,16 +13260,6 @@
                 </a:solidFill>
               </a:rPr>
             </a:br>
-            <a:r>
-              <a:rPr lang="en-US" dirty="0">
-                <a:solidFill>
-                  <a:schemeClr val="accent6">
-                    <a:lumMod val="75000"/>
-                  </a:schemeClr>
-                </a:solidFill>
-              </a:rPr>
-              <a:t/>
-            </a:r>
             <a:br>
               <a:rPr lang="en-US" dirty="0">
                 <a:solidFill>
@@ -13388,16 +13394,6 @@
                 </a:solidFill>
               </a:rPr>
             </a:br>
-            <a:r>
-              <a:rPr lang="en-US" dirty="0">
-                <a:solidFill>
-                  <a:schemeClr val="accent6">
-                    <a:lumMod val="75000"/>
-                  </a:schemeClr>
-                </a:solidFill>
-              </a:rPr>
-              <a:t/>
-            </a:r>
             <a:br>
               <a:rPr lang="en-US" dirty="0">
                 <a:solidFill>
@@ -13867,16 +13863,6 @@
                 </a:solidFill>
               </a:rPr>
             </a:br>
-            <a:r>
-              <a:rPr lang="en-US" dirty="0">
-                <a:solidFill>
-                  <a:schemeClr val="accent6">
-                    <a:lumMod val="75000"/>
-                  </a:schemeClr>
-                </a:solidFill>
-              </a:rPr>
-              <a:t/>
-            </a:r>
             <a:br>
               <a:rPr lang="en-US" dirty="0">
                 <a:solidFill>
@@ -14317,7 +14303,7 @@
           <p:cNvPr id="12" name="TextBox 5">
             <a:extLst>
               <a:ext uri="{FF2B5EF4-FFF2-40B4-BE49-F238E27FC236}">
-                <a16:creationId xmlns:a16="http://schemas.microsoft.com/office/drawing/2014/main" xmlns="" id="{3DED9120-48D0-461A-ABDA-6BF0C46FF675}"/>
+                <a16:creationId xmlns:a16="http://schemas.microsoft.com/office/drawing/2014/main" id="{3DED9120-48D0-461A-ABDA-6BF0C46FF675}"/>
               </a:ext>
             </a:extLst>
           </p:cNvPr>
@@ -14476,7 +14462,7 @@
           <p:cNvPr id="3" name="Group 2">
             <a:extLst>
               <a:ext uri="{FF2B5EF4-FFF2-40B4-BE49-F238E27FC236}">
-                <a16:creationId xmlns:a16="http://schemas.microsoft.com/office/drawing/2014/main" xmlns="" id="{5507C6A9-AFBA-40BD-AED4-EB560FE1481C}"/>
+                <a16:creationId xmlns:a16="http://schemas.microsoft.com/office/drawing/2014/main" id="{5507C6A9-AFBA-40BD-AED4-EB560FE1481C}"/>
               </a:ext>
             </a:extLst>
           </p:cNvPr>
@@ -14496,7 +14482,7 @@
             <p:cNvPr id="6" name="Group 5">
               <a:extLst>
                 <a:ext uri="{FF2B5EF4-FFF2-40B4-BE49-F238E27FC236}">
-                  <a16:creationId xmlns:a16="http://schemas.microsoft.com/office/drawing/2014/main" xmlns="" id="{3B58C20D-AA9E-4656-B5C2-4D8F08FA92D9}"/>
+                  <a16:creationId xmlns:a16="http://schemas.microsoft.com/office/drawing/2014/main" id="{3B58C20D-AA9E-4656-B5C2-4D8F08FA92D9}"/>
                 </a:ext>
               </a:extLst>
             </p:cNvPr>
@@ -14516,7 +14502,7 @@
               <p:cNvPr id="7" name="Rectangle 6">
                 <a:extLst>
                   <a:ext uri="{FF2B5EF4-FFF2-40B4-BE49-F238E27FC236}">
-                    <a16:creationId xmlns:a16="http://schemas.microsoft.com/office/drawing/2014/main" xmlns="" id="{DFB7AA70-5C24-463E-9FBB-035F4B563690}"/>
+                    <a16:creationId xmlns:a16="http://schemas.microsoft.com/office/drawing/2014/main" id="{DFB7AA70-5C24-463E-9FBB-035F4B563690}"/>
                   </a:ext>
                 </a:extLst>
               </p:cNvPr>
@@ -14566,7 +14552,7 @@
               <p:cNvPr id="8" name="Rectangle 4">
                 <a:extLst>
                   <a:ext uri="{FF2B5EF4-FFF2-40B4-BE49-F238E27FC236}">
-                    <a16:creationId xmlns:a16="http://schemas.microsoft.com/office/drawing/2014/main" xmlns="" id="{259EFE20-9A45-4786-8E77-670ACE26B674}"/>
+                    <a16:creationId xmlns:a16="http://schemas.microsoft.com/office/drawing/2014/main" id="{259EFE20-9A45-4786-8E77-670ACE26B674}"/>
                   </a:ext>
                 </a:extLst>
               </p:cNvPr>
@@ -14666,7 +14652,7 @@
             <p:cNvPr id="9" name="Rectangle: Rounded Corners 8">
               <a:extLst>
                 <a:ext uri="{FF2B5EF4-FFF2-40B4-BE49-F238E27FC236}">
-                  <a16:creationId xmlns:a16="http://schemas.microsoft.com/office/drawing/2014/main" xmlns="" id="{9DC380AE-3C3D-41B7-BAD4-BA3753083BA3}"/>
+                  <a16:creationId xmlns:a16="http://schemas.microsoft.com/office/drawing/2014/main" id="{9DC380AE-3C3D-41B7-BAD4-BA3753083BA3}"/>
                 </a:ext>
               </a:extLst>
             </p:cNvPr>
@@ -14718,7 +14704,7 @@
             <p:cNvPr id="10" name="Rectangle: Rounded Corners 9">
               <a:extLst>
                 <a:ext uri="{FF2B5EF4-FFF2-40B4-BE49-F238E27FC236}">
-                  <a16:creationId xmlns:a16="http://schemas.microsoft.com/office/drawing/2014/main" xmlns="" id="{42B36113-62CA-4730-A8CC-2627DE8C58BA}"/>
+                  <a16:creationId xmlns:a16="http://schemas.microsoft.com/office/drawing/2014/main" id="{42B36113-62CA-4730-A8CC-2627DE8C58BA}"/>
                 </a:ext>
               </a:extLst>
             </p:cNvPr>
@@ -14770,7 +14756,7 @@
             <p:cNvPr id="11" name="Rectangle: Rounded Corners 10">
               <a:extLst>
                 <a:ext uri="{FF2B5EF4-FFF2-40B4-BE49-F238E27FC236}">
-                  <a16:creationId xmlns:a16="http://schemas.microsoft.com/office/drawing/2014/main" xmlns="" id="{D90DA417-509B-4994-BA62-0E84A410C360}"/>
+                  <a16:creationId xmlns:a16="http://schemas.microsoft.com/office/drawing/2014/main" id="{D90DA417-509B-4994-BA62-0E84A410C360}"/>
                 </a:ext>
               </a:extLst>
             </p:cNvPr>
@@ -14822,7 +14808,7 @@
             <p:cNvPr id="12" name="Rectangle: Rounded Corners 11">
               <a:extLst>
                 <a:ext uri="{FF2B5EF4-FFF2-40B4-BE49-F238E27FC236}">
-                  <a16:creationId xmlns:a16="http://schemas.microsoft.com/office/drawing/2014/main" xmlns="" id="{19DE6D20-4484-43F8-A935-62B309C5780C}"/>
+                  <a16:creationId xmlns:a16="http://schemas.microsoft.com/office/drawing/2014/main" id="{19DE6D20-4484-43F8-A935-62B309C5780C}"/>
                 </a:ext>
               </a:extLst>
             </p:cNvPr>
@@ -14874,7 +14860,7 @@
             <p:cNvPr id="13" name="Rectangle: Rounded Corners 12">
               <a:extLst>
                 <a:ext uri="{FF2B5EF4-FFF2-40B4-BE49-F238E27FC236}">
-                  <a16:creationId xmlns:a16="http://schemas.microsoft.com/office/drawing/2014/main" xmlns="" id="{0ABC8302-8409-4245-B7FE-C796188F375E}"/>
+                  <a16:creationId xmlns:a16="http://schemas.microsoft.com/office/drawing/2014/main" id="{0ABC8302-8409-4245-B7FE-C796188F375E}"/>
                 </a:ext>
               </a:extLst>
             </p:cNvPr>
@@ -14926,7 +14912,7 @@
             <p:cNvPr id="14" name="Rectangle: Rounded Corners 13">
               <a:extLst>
                 <a:ext uri="{FF2B5EF4-FFF2-40B4-BE49-F238E27FC236}">
-                  <a16:creationId xmlns:a16="http://schemas.microsoft.com/office/drawing/2014/main" xmlns="" id="{6165C864-0BD7-4E65-AE82-F6744BB188F6}"/>
+                  <a16:creationId xmlns:a16="http://schemas.microsoft.com/office/drawing/2014/main" id="{6165C864-0BD7-4E65-AE82-F6744BB188F6}"/>
                 </a:ext>
               </a:extLst>
             </p:cNvPr>
@@ -15860,7 +15846,7 @@
           <p:cNvPr id="2" name="Group 1">
             <a:extLst>
               <a:ext uri="{FF2B5EF4-FFF2-40B4-BE49-F238E27FC236}">
-                <a16:creationId xmlns:a16="http://schemas.microsoft.com/office/drawing/2014/main" xmlns="" id="{82628079-219E-4395-829A-850E6312DDEF}"/>
+                <a16:creationId xmlns:a16="http://schemas.microsoft.com/office/drawing/2014/main" id="{82628079-219E-4395-829A-850E6312DDEF}"/>
               </a:ext>
             </a:extLst>
           </p:cNvPr>
@@ -15880,7 +15866,7 @@
             <p:cNvPr id="6" name="Group 5">
               <a:extLst>
                 <a:ext uri="{FF2B5EF4-FFF2-40B4-BE49-F238E27FC236}">
-                  <a16:creationId xmlns:a16="http://schemas.microsoft.com/office/drawing/2014/main" xmlns="" id="{5ABBAD16-CB81-4226-859D-4301BC41920D}"/>
+                  <a16:creationId xmlns:a16="http://schemas.microsoft.com/office/drawing/2014/main" id="{5ABBAD16-CB81-4226-859D-4301BC41920D}"/>
                 </a:ext>
               </a:extLst>
             </p:cNvPr>
@@ -15900,7 +15886,7 @@
               <p:cNvPr id="7" name="Rectangle 6">
                 <a:extLst>
                   <a:ext uri="{FF2B5EF4-FFF2-40B4-BE49-F238E27FC236}">
-                    <a16:creationId xmlns:a16="http://schemas.microsoft.com/office/drawing/2014/main" xmlns="" id="{F2166D96-A0C1-4CA1-A996-089706AE2064}"/>
+                    <a16:creationId xmlns:a16="http://schemas.microsoft.com/office/drawing/2014/main" id="{F2166D96-A0C1-4CA1-A996-089706AE2064}"/>
                   </a:ext>
                 </a:extLst>
               </p:cNvPr>
@@ -15950,7 +15936,7 @@
               <p:cNvPr id="8" name="Rectangle 4">
                 <a:extLst>
                   <a:ext uri="{FF2B5EF4-FFF2-40B4-BE49-F238E27FC236}">
-                    <a16:creationId xmlns:a16="http://schemas.microsoft.com/office/drawing/2014/main" xmlns="" id="{E55DEF46-C82C-4AC0-9F7F-216DD65B664D}"/>
+                    <a16:creationId xmlns:a16="http://schemas.microsoft.com/office/drawing/2014/main" id="{E55DEF46-C82C-4AC0-9F7F-216DD65B664D}"/>
                   </a:ext>
                 </a:extLst>
               </p:cNvPr>
@@ -16050,7 +16036,7 @@
             <p:cNvPr id="9" name="Group 8">
               <a:extLst>
                 <a:ext uri="{FF2B5EF4-FFF2-40B4-BE49-F238E27FC236}">
-                  <a16:creationId xmlns:a16="http://schemas.microsoft.com/office/drawing/2014/main" xmlns="" id="{F7395747-2B54-4CA0-8A3B-586422E7CF4B}"/>
+                  <a16:creationId xmlns:a16="http://schemas.microsoft.com/office/drawing/2014/main" id="{F7395747-2B54-4CA0-8A3B-586422E7CF4B}"/>
                 </a:ext>
               </a:extLst>
             </p:cNvPr>
@@ -16070,7 +16056,7 @@
               <p:cNvPr id="10" name="Rectangle 9">
                 <a:extLst>
                   <a:ext uri="{FF2B5EF4-FFF2-40B4-BE49-F238E27FC236}">
-                    <a16:creationId xmlns:a16="http://schemas.microsoft.com/office/drawing/2014/main" xmlns="" id="{F8DCBE5E-D562-43A6-A7A6-C758E6C349D5}"/>
+                    <a16:creationId xmlns:a16="http://schemas.microsoft.com/office/drawing/2014/main" id="{F8DCBE5E-D562-43A6-A7A6-C758E6C349D5}"/>
                   </a:ext>
                 </a:extLst>
               </p:cNvPr>
@@ -16122,7 +16108,7 @@
               <p:cNvPr id="11" name="Rectangle 10">
                 <a:extLst>
                   <a:ext uri="{FF2B5EF4-FFF2-40B4-BE49-F238E27FC236}">
-                    <a16:creationId xmlns:a16="http://schemas.microsoft.com/office/drawing/2014/main" xmlns="" id="{603311A3-2FD4-461F-9C90-BF0505381F29}"/>
+                    <a16:creationId xmlns:a16="http://schemas.microsoft.com/office/drawing/2014/main" id="{603311A3-2FD4-461F-9C90-BF0505381F29}"/>
                   </a:ext>
                 </a:extLst>
               </p:cNvPr>
@@ -16175,7 +16161,7 @@
             <p:cNvPr id="12" name="5-Point Star 35">
               <a:extLst>
                 <a:ext uri="{FF2B5EF4-FFF2-40B4-BE49-F238E27FC236}">
-                  <a16:creationId xmlns:a16="http://schemas.microsoft.com/office/drawing/2014/main" xmlns="" id="{02D982F7-B4BD-4FE0-82B0-0A0B6287A7E4}"/>
+                  <a16:creationId xmlns:a16="http://schemas.microsoft.com/office/drawing/2014/main" id="{02D982F7-B4BD-4FE0-82B0-0A0B6287A7E4}"/>
                 </a:ext>
               </a:extLst>
             </p:cNvPr>
@@ -16227,7 +16213,7 @@
             <p:cNvPr id="13" name="5-Point Star 62">
               <a:extLst>
                 <a:ext uri="{FF2B5EF4-FFF2-40B4-BE49-F238E27FC236}">
-                  <a16:creationId xmlns:a16="http://schemas.microsoft.com/office/drawing/2014/main" xmlns="" id="{8CBDA86A-A898-4564-A1FD-F33FE581A137}"/>
+                  <a16:creationId xmlns:a16="http://schemas.microsoft.com/office/drawing/2014/main" id="{8CBDA86A-A898-4564-A1FD-F33FE581A137}"/>
                 </a:ext>
               </a:extLst>
             </p:cNvPr>
@@ -16279,7 +16265,7 @@
             <p:cNvPr id="14" name="5-Point Star 63">
               <a:extLst>
                 <a:ext uri="{FF2B5EF4-FFF2-40B4-BE49-F238E27FC236}">
-                  <a16:creationId xmlns:a16="http://schemas.microsoft.com/office/drawing/2014/main" xmlns="" id="{6F298BAB-3B90-4035-B940-D89D7DC878CF}"/>
+                  <a16:creationId xmlns:a16="http://schemas.microsoft.com/office/drawing/2014/main" id="{6F298BAB-3B90-4035-B940-D89D7DC878CF}"/>
                 </a:ext>
               </a:extLst>
             </p:cNvPr>
@@ -19432,7 +19418,7 @@
           <p:cNvPr id="14" name="TextBox 10">
             <a:extLst>
               <a:ext uri="{FF2B5EF4-FFF2-40B4-BE49-F238E27FC236}">
-                <a16:creationId xmlns:a16="http://schemas.microsoft.com/office/drawing/2014/main" xmlns="" id="{7BBC55F3-38CC-4259-AE73-264693F4ED8F}"/>
+                <a16:creationId xmlns:a16="http://schemas.microsoft.com/office/drawing/2014/main" id="{7BBC55F3-38CC-4259-AE73-264693F4ED8F}"/>
               </a:ext>
             </a:extLst>
           </p:cNvPr>
@@ -19473,7 +19459,7 @@
           <p:cNvPr id="7" name="Group 6">
             <a:extLst>
               <a:ext uri="{FF2B5EF4-FFF2-40B4-BE49-F238E27FC236}">
-                <a16:creationId xmlns:a16="http://schemas.microsoft.com/office/drawing/2014/main" xmlns="" id="{CAB7D6B1-424B-4597-B416-B16AAE517A6A}"/>
+                <a16:creationId xmlns:a16="http://schemas.microsoft.com/office/drawing/2014/main" id="{CAB7D6B1-424B-4597-B416-B16AAE517A6A}"/>
               </a:ext>
             </a:extLst>
           </p:cNvPr>
@@ -19493,7 +19479,7 @@
             <p:cNvPr id="8" name="Group 7">
               <a:extLst>
                 <a:ext uri="{FF2B5EF4-FFF2-40B4-BE49-F238E27FC236}">
-                  <a16:creationId xmlns:a16="http://schemas.microsoft.com/office/drawing/2014/main" xmlns="" id="{836FFC91-DCC8-4659-BC4D-504AA1CED7C5}"/>
+                  <a16:creationId xmlns:a16="http://schemas.microsoft.com/office/drawing/2014/main" id="{836FFC91-DCC8-4659-BC4D-504AA1CED7C5}"/>
                 </a:ext>
               </a:extLst>
             </p:cNvPr>
@@ -19515,7 +19501,7 @@
               <p:cNvPr id="12" name="Rectangle 11">
                 <a:extLst>
                   <a:ext uri="{FF2B5EF4-FFF2-40B4-BE49-F238E27FC236}">
-                    <a16:creationId xmlns:a16="http://schemas.microsoft.com/office/drawing/2014/main" xmlns="" id="{BCB67652-6F70-4AAF-A112-EED91B9AD09E}"/>
+                    <a16:creationId xmlns:a16="http://schemas.microsoft.com/office/drawing/2014/main" id="{BCB67652-6F70-4AAF-A112-EED91B9AD09E}"/>
                   </a:ext>
                 </a:extLst>
               </p:cNvPr>
@@ -19565,7 +19551,7 @@
               <p:cNvPr id="13" name="Rectangle 4">
                 <a:extLst>
                   <a:ext uri="{FF2B5EF4-FFF2-40B4-BE49-F238E27FC236}">
-                    <a16:creationId xmlns:a16="http://schemas.microsoft.com/office/drawing/2014/main" xmlns="" id="{D11F5DD7-C564-4163-9EF7-64D7F78B8A7E}"/>
+                    <a16:creationId xmlns:a16="http://schemas.microsoft.com/office/drawing/2014/main" id="{D11F5DD7-C564-4163-9EF7-64D7F78B8A7E}"/>
                   </a:ext>
                 </a:extLst>
               </p:cNvPr>
@@ -19665,7 +19651,7 @@
             <p:cNvPr id="9" name="Rectangle 7">
               <a:extLst>
                 <a:ext uri="{FF2B5EF4-FFF2-40B4-BE49-F238E27FC236}">
-                  <a16:creationId xmlns:a16="http://schemas.microsoft.com/office/drawing/2014/main" xmlns="" id="{F9FD2565-0778-486B-8BF1-8FCADB5C50C1}"/>
+                  <a16:creationId xmlns:a16="http://schemas.microsoft.com/office/drawing/2014/main" id="{F9FD2565-0778-486B-8BF1-8FCADB5C50C1}"/>
                 </a:ext>
               </a:extLst>
             </p:cNvPr>
@@ -19721,7 +19707,7 @@
             <p:cNvPr id="10" name="Rectangle 7">
               <a:extLst>
                 <a:ext uri="{FF2B5EF4-FFF2-40B4-BE49-F238E27FC236}">
-                  <a16:creationId xmlns:a16="http://schemas.microsoft.com/office/drawing/2014/main" xmlns="" id="{8B3A62F3-C5EA-48EE-B00B-F72F2A850805}"/>
+                  <a16:creationId xmlns:a16="http://schemas.microsoft.com/office/drawing/2014/main" id="{8B3A62F3-C5EA-48EE-B00B-F72F2A850805}"/>
                 </a:ext>
               </a:extLst>
             </p:cNvPr>
@@ -19777,7 +19763,7 @@
             <p:cNvPr id="11" name="Straight Connector 10">
               <a:extLst>
                 <a:ext uri="{FF2B5EF4-FFF2-40B4-BE49-F238E27FC236}">
-                  <a16:creationId xmlns:a16="http://schemas.microsoft.com/office/drawing/2014/main" xmlns="" id="{BE4D4265-4B0A-4E84-BC81-A5A20E533FE9}"/>
+                  <a16:creationId xmlns:a16="http://schemas.microsoft.com/office/drawing/2014/main" id="{BE4D4265-4B0A-4E84-BC81-A5A20E533FE9}"/>
                 </a:ext>
               </a:extLst>
             </p:cNvPr>
@@ -21680,7 +21666,7 @@
           <p:cNvPr id="21" name="Group 20">
             <a:extLst>
               <a:ext uri="{FF2B5EF4-FFF2-40B4-BE49-F238E27FC236}">
-                <a16:creationId xmlns:a16="http://schemas.microsoft.com/office/drawing/2014/main" xmlns="" id="{FB964B7B-2F65-40E6-8C33-F1F31CC76A40}"/>
+                <a16:creationId xmlns:a16="http://schemas.microsoft.com/office/drawing/2014/main" id="{FB964B7B-2F65-40E6-8C33-F1F31CC76A40}"/>
               </a:ext>
             </a:extLst>
           </p:cNvPr>
@@ -21700,7 +21686,7 @@
             <p:cNvPr id="22" name="Group 21">
               <a:extLst>
                 <a:ext uri="{FF2B5EF4-FFF2-40B4-BE49-F238E27FC236}">
-                  <a16:creationId xmlns:a16="http://schemas.microsoft.com/office/drawing/2014/main" xmlns="" id="{84B5D48C-004D-4582-8F3D-A8561DAD8975}"/>
+                  <a16:creationId xmlns:a16="http://schemas.microsoft.com/office/drawing/2014/main" id="{84B5D48C-004D-4582-8F3D-A8561DAD8975}"/>
                 </a:ext>
               </a:extLst>
             </p:cNvPr>
@@ -21722,7 +21708,7 @@
               <p:cNvPr id="25" name="Rectangle 24">
                 <a:extLst>
                   <a:ext uri="{FF2B5EF4-FFF2-40B4-BE49-F238E27FC236}">
-                    <a16:creationId xmlns:a16="http://schemas.microsoft.com/office/drawing/2014/main" xmlns="" id="{B25136A3-465B-41B2-8B2D-30330165A102}"/>
+                    <a16:creationId xmlns:a16="http://schemas.microsoft.com/office/drawing/2014/main" id="{B25136A3-465B-41B2-8B2D-30330165A102}"/>
                   </a:ext>
                 </a:extLst>
               </p:cNvPr>
@@ -21772,7 +21758,7 @@
               <p:cNvPr id="26" name="Rectangle 4">
                 <a:extLst>
                   <a:ext uri="{FF2B5EF4-FFF2-40B4-BE49-F238E27FC236}">
-                    <a16:creationId xmlns:a16="http://schemas.microsoft.com/office/drawing/2014/main" xmlns="" id="{254CEE61-36CE-43D3-BF32-17045F4719B1}"/>
+                    <a16:creationId xmlns:a16="http://schemas.microsoft.com/office/drawing/2014/main" id="{254CEE61-36CE-43D3-BF32-17045F4719B1}"/>
                   </a:ext>
                 </a:extLst>
               </p:cNvPr>
@@ -21872,7 +21858,7 @@
             <p:cNvPr id="23" name="Straight Arrow Connector 22">
               <a:extLst>
                 <a:ext uri="{FF2B5EF4-FFF2-40B4-BE49-F238E27FC236}">
-                  <a16:creationId xmlns:a16="http://schemas.microsoft.com/office/drawing/2014/main" xmlns="" id="{541490D4-5CDA-4A5A-83FB-B687BB1B2749}"/>
+                  <a16:creationId xmlns:a16="http://schemas.microsoft.com/office/drawing/2014/main" id="{541490D4-5CDA-4A5A-83FB-B687BB1B2749}"/>
                 </a:ext>
               </a:extLst>
             </p:cNvPr>
@@ -21915,7 +21901,7 @@
             <p:cNvPr id="24" name="Rectangle 4">
               <a:extLst>
                 <a:ext uri="{FF2B5EF4-FFF2-40B4-BE49-F238E27FC236}">
-                  <a16:creationId xmlns:a16="http://schemas.microsoft.com/office/drawing/2014/main" xmlns="" id="{BD708871-BB54-4B24-8E51-CEF411E06F04}"/>
+                  <a16:creationId xmlns:a16="http://schemas.microsoft.com/office/drawing/2014/main" id="{BD708871-BB54-4B24-8E51-CEF411E06F04}"/>
                 </a:ext>
               </a:extLst>
             </p:cNvPr>
@@ -25127,7 +25113,7 @@
           <p:cNvPr id="41" name="Group 40">
             <a:extLst>
               <a:ext uri="{FF2B5EF4-FFF2-40B4-BE49-F238E27FC236}">
-                <a16:creationId xmlns:a16="http://schemas.microsoft.com/office/drawing/2014/main" xmlns="" id="{08AE90FD-0B34-4D29-95E1-8F0BF5710F35}"/>
+                <a16:creationId xmlns:a16="http://schemas.microsoft.com/office/drawing/2014/main" id="{08AE90FD-0B34-4D29-95E1-8F0BF5710F35}"/>
               </a:ext>
             </a:extLst>
           </p:cNvPr>
@@ -25147,7 +25133,7 @@
             <p:cNvPr id="42" name="Group 41">
               <a:extLst>
                 <a:ext uri="{FF2B5EF4-FFF2-40B4-BE49-F238E27FC236}">
-                  <a16:creationId xmlns:a16="http://schemas.microsoft.com/office/drawing/2014/main" xmlns="" id="{494A811F-7E0C-4657-9C74-0BE1779A57DB}"/>
+                  <a16:creationId xmlns:a16="http://schemas.microsoft.com/office/drawing/2014/main" id="{494A811F-7E0C-4657-9C74-0BE1779A57DB}"/>
                 </a:ext>
               </a:extLst>
             </p:cNvPr>
@@ -25167,7 +25153,7 @@
               <p:cNvPr id="47" name="Rectangle 46">
                 <a:extLst>
                   <a:ext uri="{FF2B5EF4-FFF2-40B4-BE49-F238E27FC236}">
-                    <a16:creationId xmlns:a16="http://schemas.microsoft.com/office/drawing/2014/main" xmlns="" id="{7A58FE49-1C30-46A1-A8CA-B3357B336E14}"/>
+                    <a16:creationId xmlns:a16="http://schemas.microsoft.com/office/drawing/2014/main" id="{7A58FE49-1C30-46A1-A8CA-B3357B336E14}"/>
                   </a:ext>
                 </a:extLst>
               </p:cNvPr>
@@ -25217,7 +25203,7 @@
               <p:cNvPr id="48" name="Rectangle 4">
                 <a:extLst>
                   <a:ext uri="{FF2B5EF4-FFF2-40B4-BE49-F238E27FC236}">
-                    <a16:creationId xmlns:a16="http://schemas.microsoft.com/office/drawing/2014/main" xmlns="" id="{E298BF80-3E03-46D1-8B24-886607F59D22}"/>
+                    <a16:creationId xmlns:a16="http://schemas.microsoft.com/office/drawing/2014/main" id="{E298BF80-3E03-46D1-8B24-886607F59D22}"/>
                   </a:ext>
                 </a:extLst>
               </p:cNvPr>
@@ -25316,7 +25302,7 @@
               <p:cNvPr id="49" name="Freeform 70">
                 <a:extLst>
                   <a:ext uri="{FF2B5EF4-FFF2-40B4-BE49-F238E27FC236}">
-                    <a16:creationId xmlns:a16="http://schemas.microsoft.com/office/drawing/2014/main" xmlns="" id="{9EA8314E-C393-494A-A8FD-54E28BFDD178}"/>
+                    <a16:creationId xmlns:a16="http://schemas.microsoft.com/office/drawing/2014/main" id="{9EA8314E-C393-494A-A8FD-54E28BFDD178}"/>
                   </a:ext>
                 </a:extLst>
               </p:cNvPr>
@@ -25412,7 +25398,7 @@
             <p:cNvPr id="43" name="Group 42">
               <a:extLst>
                 <a:ext uri="{FF2B5EF4-FFF2-40B4-BE49-F238E27FC236}">
-                  <a16:creationId xmlns:a16="http://schemas.microsoft.com/office/drawing/2014/main" xmlns="" id="{C9482004-9ADE-4311-B6C9-784C70076DEE}"/>
+                  <a16:creationId xmlns:a16="http://schemas.microsoft.com/office/drawing/2014/main" id="{C9482004-9ADE-4311-B6C9-784C70076DEE}"/>
                 </a:ext>
               </a:extLst>
             </p:cNvPr>
@@ -25432,7 +25418,7 @@
               <p:cNvPr id="44" name="Rounded Rectangle 215">
                 <a:extLst>
                   <a:ext uri="{FF2B5EF4-FFF2-40B4-BE49-F238E27FC236}">
-                    <a16:creationId xmlns:a16="http://schemas.microsoft.com/office/drawing/2014/main" xmlns="" id="{9B3E1574-DC9B-4C5E-8720-1767F3C9A588}"/>
+                    <a16:creationId xmlns:a16="http://schemas.microsoft.com/office/drawing/2014/main" id="{9B3E1574-DC9B-4C5E-8720-1767F3C9A588}"/>
                   </a:ext>
                 </a:extLst>
               </p:cNvPr>
@@ -25616,7 +25602,7 @@
               <p:cNvPr id="45" name="Freeform: Shape 44">
                 <a:extLst>
                   <a:ext uri="{FF2B5EF4-FFF2-40B4-BE49-F238E27FC236}">
-                    <a16:creationId xmlns:a16="http://schemas.microsoft.com/office/drawing/2014/main" xmlns="" id="{653B1901-0145-482B-8956-BC0A1FCDA701}"/>
+                    <a16:creationId xmlns:a16="http://schemas.microsoft.com/office/drawing/2014/main" id="{653B1901-0145-482B-8956-BC0A1FCDA701}"/>
                   </a:ext>
                 </a:extLst>
               </p:cNvPr>
@@ -25770,7 +25756,7 @@
               <p:cNvPr id="46" name="Flowchart: Manual Input 68">
                 <a:extLst>
                   <a:ext uri="{FF2B5EF4-FFF2-40B4-BE49-F238E27FC236}">
-                    <a16:creationId xmlns:a16="http://schemas.microsoft.com/office/drawing/2014/main" xmlns="" id="{43B1FE13-E20E-483F-BB03-123DCB0EE155}"/>
+                    <a16:creationId xmlns:a16="http://schemas.microsoft.com/office/drawing/2014/main" id="{43B1FE13-E20E-483F-BB03-123DCB0EE155}"/>
                   </a:ext>
                 </a:extLst>
               </p:cNvPr>
@@ -27162,7 +27148,7 @@
           <p:cNvPr id="2" name="Group 1">
             <a:extLst>
               <a:ext uri="{FF2B5EF4-FFF2-40B4-BE49-F238E27FC236}">
-                <a16:creationId xmlns:a16="http://schemas.microsoft.com/office/drawing/2014/main" xmlns="" id="{999CC690-21B2-44F5-B609-2DF10E2DA165}"/>
+                <a16:creationId xmlns:a16="http://schemas.microsoft.com/office/drawing/2014/main" id="{999CC690-21B2-44F5-B609-2DF10E2DA165}"/>
               </a:ext>
             </a:extLst>
           </p:cNvPr>
@@ -27182,7 +27168,7 @@
             <p:cNvPr id="7" name="Group 6">
               <a:extLst>
                 <a:ext uri="{FF2B5EF4-FFF2-40B4-BE49-F238E27FC236}">
-                  <a16:creationId xmlns:a16="http://schemas.microsoft.com/office/drawing/2014/main" xmlns="" id="{9243B3B7-2DB8-42C5-AA07-420678815239}"/>
+                  <a16:creationId xmlns:a16="http://schemas.microsoft.com/office/drawing/2014/main" id="{9243B3B7-2DB8-42C5-AA07-420678815239}"/>
                 </a:ext>
               </a:extLst>
             </p:cNvPr>
@@ -27204,7 +27190,7 @@
               <p:cNvPr id="8" name="Rectangle 7">
                 <a:extLst>
                   <a:ext uri="{FF2B5EF4-FFF2-40B4-BE49-F238E27FC236}">
-                    <a16:creationId xmlns:a16="http://schemas.microsoft.com/office/drawing/2014/main" xmlns="" id="{88253732-0F8D-4E48-A4B1-73DBA240F754}"/>
+                    <a16:creationId xmlns:a16="http://schemas.microsoft.com/office/drawing/2014/main" id="{88253732-0F8D-4E48-A4B1-73DBA240F754}"/>
                   </a:ext>
                 </a:extLst>
               </p:cNvPr>
@@ -27254,7 +27240,7 @@
               <p:cNvPr id="9" name="Rectangle 4">
                 <a:extLst>
                   <a:ext uri="{FF2B5EF4-FFF2-40B4-BE49-F238E27FC236}">
-                    <a16:creationId xmlns:a16="http://schemas.microsoft.com/office/drawing/2014/main" xmlns="" id="{60FEAA54-4227-4D57-80DE-0A199394CA42}"/>
+                    <a16:creationId xmlns:a16="http://schemas.microsoft.com/office/drawing/2014/main" id="{60FEAA54-4227-4D57-80DE-0A199394CA42}"/>
                   </a:ext>
                 </a:extLst>
               </p:cNvPr>
@@ -27354,7 +27340,7 @@
             <p:cNvPr id="10" name="Rectangle 9">
               <a:extLst>
                 <a:ext uri="{FF2B5EF4-FFF2-40B4-BE49-F238E27FC236}">
-                  <a16:creationId xmlns:a16="http://schemas.microsoft.com/office/drawing/2014/main" xmlns="" id="{D5CBB84A-A807-4C19-815B-1E9418B63FB1}"/>
+                  <a16:creationId xmlns:a16="http://schemas.microsoft.com/office/drawing/2014/main" id="{D5CBB84A-A807-4C19-815B-1E9418B63FB1}"/>
                 </a:ext>
               </a:extLst>
             </p:cNvPr>
@@ -27412,7 +27398,7 @@
             <p:cNvPr id="11" name="Rectangle 10">
               <a:extLst>
                 <a:ext uri="{FF2B5EF4-FFF2-40B4-BE49-F238E27FC236}">
-                  <a16:creationId xmlns:a16="http://schemas.microsoft.com/office/drawing/2014/main" xmlns="" id="{FA7B5318-1619-482A-9D8D-CE3B4E1DE774}"/>
+                  <a16:creationId xmlns:a16="http://schemas.microsoft.com/office/drawing/2014/main" id="{FA7B5318-1619-482A-9D8D-CE3B4E1DE774}"/>
                 </a:ext>
               </a:extLst>
             </p:cNvPr>
@@ -27470,7 +27456,7 @@
             <p:cNvPr id="12" name="Arrow: Circular 11">
               <a:extLst>
                 <a:ext uri="{FF2B5EF4-FFF2-40B4-BE49-F238E27FC236}">
-                  <a16:creationId xmlns:a16="http://schemas.microsoft.com/office/drawing/2014/main" xmlns="" id="{BB611C73-3068-446A-9F4A-4EC85CE9DC42}"/>
+                  <a16:creationId xmlns:a16="http://schemas.microsoft.com/office/drawing/2014/main" id="{BB611C73-3068-446A-9F4A-4EC85CE9DC42}"/>
                 </a:ext>
               </a:extLst>
             </p:cNvPr>
@@ -27532,7 +27518,7 @@
             <p:cNvPr id="13" name="Arrow: Circular 12">
               <a:extLst>
                 <a:ext uri="{FF2B5EF4-FFF2-40B4-BE49-F238E27FC236}">
-                  <a16:creationId xmlns:a16="http://schemas.microsoft.com/office/drawing/2014/main" xmlns="" id="{96824872-4F58-4689-BF5A-3BAED028A177}"/>
+                  <a16:creationId xmlns:a16="http://schemas.microsoft.com/office/drawing/2014/main" id="{96824872-4F58-4689-BF5A-3BAED028A177}"/>
                 </a:ext>
               </a:extLst>
             </p:cNvPr>
@@ -29276,7 +29262,7 @@
           <p:cNvPr id="21" name="Group 20">
             <a:extLst>
               <a:ext uri="{FF2B5EF4-FFF2-40B4-BE49-F238E27FC236}">
-                <a16:creationId xmlns:a16="http://schemas.microsoft.com/office/drawing/2014/main" xmlns="" id="{4C4D9BD4-AAFE-47F2-B01F-74E46AA27815}"/>
+                <a16:creationId xmlns:a16="http://schemas.microsoft.com/office/drawing/2014/main" id="{4C4D9BD4-AAFE-47F2-B01F-74E46AA27815}"/>
               </a:ext>
             </a:extLst>
           </p:cNvPr>
@@ -29296,7 +29282,7 @@
             <p:cNvPr id="22" name="Rectangle 21">
               <a:extLst>
                 <a:ext uri="{FF2B5EF4-FFF2-40B4-BE49-F238E27FC236}">
-                  <a16:creationId xmlns:a16="http://schemas.microsoft.com/office/drawing/2014/main" xmlns="" id="{629E0433-CE8E-4FBA-B512-94188CB0BB00}"/>
+                  <a16:creationId xmlns:a16="http://schemas.microsoft.com/office/drawing/2014/main" id="{629E0433-CE8E-4FBA-B512-94188CB0BB00}"/>
                 </a:ext>
               </a:extLst>
             </p:cNvPr>
@@ -29346,7 +29332,7 @@
             <p:cNvPr id="23" name="Rectangle 4">
               <a:extLst>
                 <a:ext uri="{FF2B5EF4-FFF2-40B4-BE49-F238E27FC236}">
-                  <a16:creationId xmlns:a16="http://schemas.microsoft.com/office/drawing/2014/main" xmlns="" id="{8E95B772-856F-4F65-BA16-017319589325}"/>
+                  <a16:creationId xmlns:a16="http://schemas.microsoft.com/office/drawing/2014/main" id="{8E95B772-856F-4F65-BA16-017319589325}"/>
                 </a:ext>
               </a:extLst>
             </p:cNvPr>
@@ -29445,7 +29431,7 @@
             <p:cNvPr id="24" name="Teardrop 23">
               <a:extLst>
                 <a:ext uri="{FF2B5EF4-FFF2-40B4-BE49-F238E27FC236}">
-                  <a16:creationId xmlns:a16="http://schemas.microsoft.com/office/drawing/2014/main" xmlns="" id="{BBDC16BC-4E6B-4DEE-B767-AFFA53B7F8BF}"/>
+                  <a16:creationId xmlns:a16="http://schemas.microsoft.com/office/drawing/2014/main" id="{BBDC16BC-4E6B-4DEE-B767-AFFA53B7F8BF}"/>
                 </a:ext>
               </a:extLst>
             </p:cNvPr>
@@ -29500,7 +29486,7 @@
             <p:cNvPr id="25" name="Flowchart: Process 24">
               <a:extLst>
                 <a:ext uri="{FF2B5EF4-FFF2-40B4-BE49-F238E27FC236}">
-                  <a16:creationId xmlns:a16="http://schemas.microsoft.com/office/drawing/2014/main" xmlns="" id="{5DA8420B-6CAD-4669-A862-EBE079D4858F}"/>
+                  <a16:creationId xmlns:a16="http://schemas.microsoft.com/office/drawing/2014/main" id="{5DA8420B-6CAD-4669-A862-EBE079D4858F}"/>
                 </a:ext>
               </a:extLst>
             </p:cNvPr>
@@ -29555,7 +29541,7 @@
             <p:cNvPr id="26" name="Flowchart: Magnetic Disk 25">
               <a:extLst>
                 <a:ext uri="{FF2B5EF4-FFF2-40B4-BE49-F238E27FC236}">
-                  <a16:creationId xmlns:a16="http://schemas.microsoft.com/office/drawing/2014/main" xmlns="" id="{92882E95-CA01-4CF2-AC2F-F11F6F6FA489}"/>
+                  <a16:creationId xmlns:a16="http://schemas.microsoft.com/office/drawing/2014/main" id="{92882E95-CA01-4CF2-AC2F-F11F6F6FA489}"/>
                 </a:ext>
               </a:extLst>
             </p:cNvPr>
@@ -29931,7 +29917,7 @@
           <p:cNvPr id="11" name="Picture 10">
             <a:extLst>
               <a:ext uri="{FF2B5EF4-FFF2-40B4-BE49-F238E27FC236}">
-                <a16:creationId xmlns:a16="http://schemas.microsoft.com/office/drawing/2014/main" xmlns="" id="{855A0C0A-D5ED-4048-83D4-508F1CB9D68B}"/>
+                <a16:creationId xmlns:a16="http://schemas.microsoft.com/office/drawing/2014/main" id="{855A0C0A-D5ED-4048-83D4-508F1CB9D68B}"/>
               </a:ext>
             </a:extLst>
           </p:cNvPr>
@@ -29961,7 +29947,7 @@
           <p:cNvPr id="13" name="Picture 12">
             <a:extLst>
               <a:ext uri="{FF2B5EF4-FFF2-40B4-BE49-F238E27FC236}">
-                <a16:creationId xmlns:a16="http://schemas.microsoft.com/office/drawing/2014/main" xmlns="" id="{0E89349E-D08C-4173-B0C7-FE1FBD5E670E}"/>
+                <a16:creationId xmlns:a16="http://schemas.microsoft.com/office/drawing/2014/main" id="{0E89349E-D08C-4173-B0C7-FE1FBD5E670E}"/>
               </a:ext>
             </a:extLst>
           </p:cNvPr>
@@ -30283,7 +30269,7 @@
           <p:cNvPr id="3" name="Picture 2">
             <a:extLst>
               <a:ext uri="{FF2B5EF4-FFF2-40B4-BE49-F238E27FC236}">
-                <a16:creationId xmlns:a16="http://schemas.microsoft.com/office/drawing/2014/main" xmlns="" id="{36EF47D2-E249-4F95-94DE-5979C3A133AB}"/>
+                <a16:creationId xmlns:a16="http://schemas.microsoft.com/office/drawing/2014/main" id="{36EF47D2-E249-4F95-94DE-5979C3A133AB}"/>
               </a:ext>
             </a:extLst>
           </p:cNvPr>
@@ -30343,7 +30329,7 @@
           <p:cNvPr id="35" name="Group 34">
             <a:extLst>
               <a:ext uri="{FF2B5EF4-FFF2-40B4-BE49-F238E27FC236}">
-                <a16:creationId xmlns:a16="http://schemas.microsoft.com/office/drawing/2014/main" xmlns="" id="{C8E50809-4FB8-435E-90D4-70A7343740E9}"/>
+                <a16:creationId xmlns:a16="http://schemas.microsoft.com/office/drawing/2014/main" id="{C8E50809-4FB8-435E-90D4-70A7343740E9}"/>
               </a:ext>
             </a:extLst>
           </p:cNvPr>
@@ -30363,7 +30349,7 @@
             <p:cNvPr id="36" name="Group 35">
               <a:extLst>
                 <a:ext uri="{FF2B5EF4-FFF2-40B4-BE49-F238E27FC236}">
-                  <a16:creationId xmlns:a16="http://schemas.microsoft.com/office/drawing/2014/main" xmlns="" id="{C3115AA1-E23B-422B-B0BC-8D56856E433B}"/>
+                  <a16:creationId xmlns:a16="http://schemas.microsoft.com/office/drawing/2014/main" id="{C3115AA1-E23B-422B-B0BC-8D56856E433B}"/>
                 </a:ext>
               </a:extLst>
             </p:cNvPr>
@@ -30383,7 +30369,7 @@
               <p:cNvPr id="45" name="Rectangle 44">
                 <a:extLst>
                   <a:ext uri="{FF2B5EF4-FFF2-40B4-BE49-F238E27FC236}">
-                    <a16:creationId xmlns:a16="http://schemas.microsoft.com/office/drawing/2014/main" xmlns="" id="{2A0D1470-81F5-4AA5-B40D-7942BA8C5C3A}"/>
+                    <a16:creationId xmlns:a16="http://schemas.microsoft.com/office/drawing/2014/main" id="{2A0D1470-81F5-4AA5-B40D-7942BA8C5C3A}"/>
                   </a:ext>
                 </a:extLst>
               </p:cNvPr>
@@ -30433,7 +30419,7 @@
               <p:cNvPr id="46" name="Rectangle 4">
                 <a:extLst>
                   <a:ext uri="{FF2B5EF4-FFF2-40B4-BE49-F238E27FC236}">
-                    <a16:creationId xmlns:a16="http://schemas.microsoft.com/office/drawing/2014/main" xmlns="" id="{B4D5FD70-1C59-4C62-AE3C-A6F594E3DE5F}"/>
+                    <a16:creationId xmlns:a16="http://schemas.microsoft.com/office/drawing/2014/main" id="{B4D5FD70-1C59-4C62-AE3C-A6F594E3DE5F}"/>
                   </a:ext>
                 </a:extLst>
               </p:cNvPr>
@@ -30533,7 +30519,7 @@
             <p:cNvPr id="37" name="Group 36">
               <a:extLst>
                 <a:ext uri="{FF2B5EF4-FFF2-40B4-BE49-F238E27FC236}">
-                  <a16:creationId xmlns:a16="http://schemas.microsoft.com/office/drawing/2014/main" xmlns="" id="{4B76E119-A237-4377-9536-488F4D5629AB}"/>
+                  <a16:creationId xmlns:a16="http://schemas.microsoft.com/office/drawing/2014/main" id="{4B76E119-A237-4377-9536-488F4D5629AB}"/>
                 </a:ext>
               </a:extLst>
             </p:cNvPr>
@@ -30553,7 +30539,7 @@
               <p:cNvPr id="38" name="Picture 37">
                 <a:extLst>
                   <a:ext uri="{FF2B5EF4-FFF2-40B4-BE49-F238E27FC236}">
-                    <a16:creationId xmlns:a16="http://schemas.microsoft.com/office/drawing/2014/main" xmlns="" id="{78E5B8F5-1B9E-4CA2-AB21-0B028E0A250B}"/>
+                    <a16:creationId xmlns:a16="http://schemas.microsoft.com/office/drawing/2014/main" id="{78E5B8F5-1B9E-4CA2-AB21-0B028E0A250B}"/>
                   </a:ext>
                 </a:extLst>
               </p:cNvPr>
@@ -30583,7 +30569,7 @@
               <p:cNvPr id="39" name="Group 19">
                 <a:extLst>
                   <a:ext uri="{FF2B5EF4-FFF2-40B4-BE49-F238E27FC236}">
-                    <a16:creationId xmlns:a16="http://schemas.microsoft.com/office/drawing/2014/main" xmlns="" id="{DA913188-684E-42CF-92A1-D805448D4DF4}"/>
+                    <a16:creationId xmlns:a16="http://schemas.microsoft.com/office/drawing/2014/main" id="{DA913188-684E-42CF-92A1-D805448D4DF4}"/>
                   </a:ext>
                 </a:extLst>
               </p:cNvPr>
@@ -30603,7 +30589,7 @@
                 <p:cNvPr id="43" name="Straight Connector 42">
                   <a:extLst>
                     <a:ext uri="{FF2B5EF4-FFF2-40B4-BE49-F238E27FC236}">
-                      <a16:creationId xmlns:a16="http://schemas.microsoft.com/office/drawing/2014/main" xmlns="" id="{37EFCB70-EA21-4DBA-80CC-BFAD92E4D22C}"/>
+                      <a16:creationId xmlns:a16="http://schemas.microsoft.com/office/drawing/2014/main" id="{37EFCB70-EA21-4DBA-80CC-BFAD92E4D22C}"/>
                     </a:ext>
                   </a:extLst>
                 </p:cNvPr>
@@ -30644,7 +30630,7 @@
                 <p:cNvPr id="44" name="Straight Connector 43">
                   <a:extLst>
                     <a:ext uri="{FF2B5EF4-FFF2-40B4-BE49-F238E27FC236}">
-                      <a16:creationId xmlns:a16="http://schemas.microsoft.com/office/drawing/2014/main" xmlns="" id="{554CF0D4-76A3-4DD9-A7D5-C9E3365A0541}"/>
+                      <a16:creationId xmlns:a16="http://schemas.microsoft.com/office/drawing/2014/main" id="{554CF0D4-76A3-4DD9-A7D5-C9E3365A0541}"/>
                     </a:ext>
                   </a:extLst>
                 </p:cNvPr>
@@ -30686,7 +30672,7 @@
               <p:cNvPr id="40" name="Group 19">
                 <a:extLst>
                   <a:ext uri="{FF2B5EF4-FFF2-40B4-BE49-F238E27FC236}">
-                    <a16:creationId xmlns:a16="http://schemas.microsoft.com/office/drawing/2014/main" xmlns="" id="{E1837D1A-D982-470E-A9DE-6BDED6404575}"/>
+                    <a16:creationId xmlns:a16="http://schemas.microsoft.com/office/drawing/2014/main" id="{E1837D1A-D982-470E-A9DE-6BDED6404575}"/>
                   </a:ext>
                 </a:extLst>
               </p:cNvPr>
@@ -30706,7 +30692,7 @@
                 <p:cNvPr id="41" name="Straight Connector 40">
                   <a:extLst>
                     <a:ext uri="{FF2B5EF4-FFF2-40B4-BE49-F238E27FC236}">
-                      <a16:creationId xmlns:a16="http://schemas.microsoft.com/office/drawing/2014/main" xmlns="" id="{B69734E3-F51F-4FC9-A3F8-380C9E092FAC}"/>
+                      <a16:creationId xmlns:a16="http://schemas.microsoft.com/office/drawing/2014/main" id="{B69734E3-F51F-4FC9-A3F8-380C9E092FAC}"/>
                     </a:ext>
                   </a:extLst>
                 </p:cNvPr>
@@ -30747,7 +30733,7 @@
                 <p:cNvPr id="42" name="Straight Connector 41">
                   <a:extLst>
                     <a:ext uri="{FF2B5EF4-FFF2-40B4-BE49-F238E27FC236}">
-                      <a16:creationId xmlns:a16="http://schemas.microsoft.com/office/drawing/2014/main" xmlns="" id="{507C5813-9AF7-4883-ACD3-DC4420374C1E}"/>
+                      <a16:creationId xmlns:a16="http://schemas.microsoft.com/office/drawing/2014/main" id="{507C5813-9AF7-4883-ACD3-DC4420374C1E}"/>
                     </a:ext>
                   </a:extLst>
                 </p:cNvPr>
@@ -30918,7 +30904,7 @@
           <p:cNvPr id="3" name="Group 2">
             <a:extLst>
               <a:ext uri="{FF2B5EF4-FFF2-40B4-BE49-F238E27FC236}">
-                <a16:creationId xmlns:a16="http://schemas.microsoft.com/office/drawing/2014/main" xmlns="" id="{FAB8C925-751C-4023-9BC7-CA83F34B2873}"/>
+                <a16:creationId xmlns:a16="http://schemas.microsoft.com/office/drawing/2014/main" id="{FAB8C925-751C-4023-9BC7-CA83F34B2873}"/>
               </a:ext>
             </a:extLst>
           </p:cNvPr>
@@ -30938,7 +30924,7 @@
             <p:cNvPr id="10" name="Straight Connector 9">
               <a:extLst>
                 <a:ext uri="{FF2B5EF4-FFF2-40B4-BE49-F238E27FC236}">
-                  <a16:creationId xmlns:a16="http://schemas.microsoft.com/office/drawing/2014/main" xmlns="" id="{483B3F28-8573-4421-9B19-6BADEC445947}"/>
+                  <a16:creationId xmlns:a16="http://schemas.microsoft.com/office/drawing/2014/main" id="{483B3F28-8573-4421-9B19-6BADEC445947}"/>
                 </a:ext>
               </a:extLst>
             </p:cNvPr>
@@ -30981,7 +30967,7 @@
             <p:cNvPr id="11" name="Straight Connector 10">
               <a:extLst>
                 <a:ext uri="{FF2B5EF4-FFF2-40B4-BE49-F238E27FC236}">
-                  <a16:creationId xmlns:a16="http://schemas.microsoft.com/office/drawing/2014/main" xmlns="" id="{6F7C6DC6-28D9-42C0-8B6D-5519E712A589}"/>
+                  <a16:creationId xmlns:a16="http://schemas.microsoft.com/office/drawing/2014/main" id="{6F7C6DC6-28D9-42C0-8B6D-5519E712A589}"/>
                 </a:ext>
               </a:extLst>
             </p:cNvPr>
@@ -31024,7 +31010,7 @@
             <p:cNvPr id="12" name="Straight Connector 11">
               <a:extLst>
                 <a:ext uri="{FF2B5EF4-FFF2-40B4-BE49-F238E27FC236}">
-                  <a16:creationId xmlns:a16="http://schemas.microsoft.com/office/drawing/2014/main" xmlns="" id="{400F9BDE-882B-4495-8012-8BD8EADD871A}"/>
+                  <a16:creationId xmlns:a16="http://schemas.microsoft.com/office/drawing/2014/main" id="{400F9BDE-882B-4495-8012-8BD8EADD871A}"/>
                 </a:ext>
               </a:extLst>
             </p:cNvPr>
@@ -31065,7 +31051,7 @@
             <p:cNvPr id="13" name="Group 12">
               <a:extLst>
                 <a:ext uri="{FF2B5EF4-FFF2-40B4-BE49-F238E27FC236}">
-                  <a16:creationId xmlns:a16="http://schemas.microsoft.com/office/drawing/2014/main" xmlns="" id="{28F0BB3E-B435-4380-B080-47593240890C}"/>
+                  <a16:creationId xmlns:a16="http://schemas.microsoft.com/office/drawing/2014/main" id="{28F0BB3E-B435-4380-B080-47593240890C}"/>
                 </a:ext>
               </a:extLst>
             </p:cNvPr>
@@ -31085,7 +31071,7 @@
               <p:cNvPr id="14" name="Rectangle 13">
                 <a:extLst>
                   <a:ext uri="{FF2B5EF4-FFF2-40B4-BE49-F238E27FC236}">
-                    <a16:creationId xmlns:a16="http://schemas.microsoft.com/office/drawing/2014/main" xmlns="" id="{D08262A5-C45B-4C51-81B7-2DCE58ACA7DB}"/>
+                    <a16:creationId xmlns:a16="http://schemas.microsoft.com/office/drawing/2014/main" id="{D08262A5-C45B-4C51-81B7-2DCE58ACA7DB}"/>
                   </a:ext>
                 </a:extLst>
               </p:cNvPr>
@@ -31135,7 +31121,7 @@
               <p:cNvPr id="15" name="Rectangle 4">
                 <a:extLst>
                   <a:ext uri="{FF2B5EF4-FFF2-40B4-BE49-F238E27FC236}">
-                    <a16:creationId xmlns:a16="http://schemas.microsoft.com/office/drawing/2014/main" xmlns="" id="{0105956D-81E1-4217-AC7C-D93AD3C32BDB}"/>
+                    <a16:creationId xmlns:a16="http://schemas.microsoft.com/office/drawing/2014/main" id="{0105956D-81E1-4217-AC7C-D93AD3C32BDB}"/>
                   </a:ext>
                 </a:extLst>
               </p:cNvPr>
@@ -31235,7 +31221,7 @@
             <p:cNvPr id="16" name="Star: 5 Points 15">
               <a:extLst>
                 <a:ext uri="{FF2B5EF4-FFF2-40B4-BE49-F238E27FC236}">
-                  <a16:creationId xmlns:a16="http://schemas.microsoft.com/office/drawing/2014/main" xmlns="" id="{7304DDFB-678C-4D2D-9901-31A2D2762127}"/>
+                  <a16:creationId xmlns:a16="http://schemas.microsoft.com/office/drawing/2014/main" id="{7304DDFB-678C-4D2D-9901-31A2D2762127}"/>
                 </a:ext>
               </a:extLst>
             </p:cNvPr>
@@ -31653,7 +31639,7 @@
           <p:cNvPr id="71" name="Picture 8" descr="File:Paul, George &amp; John.png">
             <a:extLst>
               <a:ext uri="{FF2B5EF4-FFF2-40B4-BE49-F238E27FC236}">
-                <a16:creationId xmlns:a16="http://schemas.microsoft.com/office/drawing/2014/main" xmlns="" id="{3B1C8C0C-0FB0-421D-BEA0-173F555297E1}"/>
+                <a16:creationId xmlns:a16="http://schemas.microsoft.com/office/drawing/2014/main" id="{3B1C8C0C-0FB0-421D-BEA0-173F555297E1}"/>
               </a:ext>
             </a:extLst>
           </p:cNvPr>
@@ -31705,7 +31691,7 @@
           <p:cNvPr id="72" name="Freeform 4">
             <a:extLst>
               <a:ext uri="{FF2B5EF4-FFF2-40B4-BE49-F238E27FC236}">
-                <a16:creationId xmlns:a16="http://schemas.microsoft.com/office/drawing/2014/main" xmlns="" id="{26AD2B46-FB2A-44D7-A66E-9F9B6E788984}"/>
+                <a16:creationId xmlns:a16="http://schemas.microsoft.com/office/drawing/2014/main" id="{26AD2B46-FB2A-44D7-A66E-9F9B6E788984}"/>
               </a:ext>
             </a:extLst>
           </p:cNvPr>
@@ -33309,7 +33295,7 @@
           <p:cNvPr id="50" name="Group 49">
             <a:extLst>
               <a:ext uri="{FF2B5EF4-FFF2-40B4-BE49-F238E27FC236}">
-                <a16:creationId xmlns:a16="http://schemas.microsoft.com/office/drawing/2014/main" xmlns="" id="{7AD89381-C413-4E97-9325-A1A6B285EB45}"/>
+                <a16:creationId xmlns:a16="http://schemas.microsoft.com/office/drawing/2014/main" id="{7AD89381-C413-4E97-9325-A1A6B285EB45}"/>
               </a:ext>
             </a:extLst>
           </p:cNvPr>
@@ -33329,7 +33315,7 @@
             <p:cNvPr id="51" name="Group 50">
               <a:extLst>
                 <a:ext uri="{FF2B5EF4-FFF2-40B4-BE49-F238E27FC236}">
-                  <a16:creationId xmlns:a16="http://schemas.microsoft.com/office/drawing/2014/main" xmlns="" id="{53C8916A-AFEF-4659-A208-5E106FDCB8A4}"/>
+                  <a16:creationId xmlns:a16="http://schemas.microsoft.com/office/drawing/2014/main" id="{53C8916A-AFEF-4659-A208-5E106FDCB8A4}"/>
                 </a:ext>
               </a:extLst>
             </p:cNvPr>
@@ -33349,7 +33335,7 @@
               <p:cNvPr id="58" name="Rectangle 57">
                 <a:extLst>
                   <a:ext uri="{FF2B5EF4-FFF2-40B4-BE49-F238E27FC236}">
-                    <a16:creationId xmlns:a16="http://schemas.microsoft.com/office/drawing/2014/main" xmlns="" id="{B7ACF926-25B0-4837-BC04-BBF7807D79F3}"/>
+                    <a16:creationId xmlns:a16="http://schemas.microsoft.com/office/drawing/2014/main" id="{B7ACF926-25B0-4837-BC04-BBF7807D79F3}"/>
                   </a:ext>
                 </a:extLst>
               </p:cNvPr>
@@ -33399,7 +33385,7 @@
               <p:cNvPr id="59" name="Rectangle 4">
                 <a:extLst>
                   <a:ext uri="{FF2B5EF4-FFF2-40B4-BE49-F238E27FC236}">
-                    <a16:creationId xmlns:a16="http://schemas.microsoft.com/office/drawing/2014/main" xmlns="" id="{2A29EA48-D526-4101-9883-E5FAFDE7E297}"/>
+                    <a16:creationId xmlns:a16="http://schemas.microsoft.com/office/drawing/2014/main" id="{2A29EA48-D526-4101-9883-E5FAFDE7E297}"/>
                   </a:ext>
                 </a:extLst>
               </p:cNvPr>
@@ -33499,7 +33485,7 @@
             <p:cNvPr id="52" name="Group 51">
               <a:extLst>
                 <a:ext uri="{FF2B5EF4-FFF2-40B4-BE49-F238E27FC236}">
-                  <a16:creationId xmlns:a16="http://schemas.microsoft.com/office/drawing/2014/main" xmlns="" id="{F57FFE62-090A-4F4D-9227-B7A4027AF0A6}"/>
+                  <a16:creationId xmlns:a16="http://schemas.microsoft.com/office/drawing/2014/main" id="{F57FFE62-090A-4F4D-9227-B7A4027AF0A6}"/>
                 </a:ext>
               </a:extLst>
             </p:cNvPr>
@@ -33519,7 +33505,7 @@
               <p:cNvPr id="53" name="Group 52">
                 <a:extLst>
                   <a:ext uri="{FF2B5EF4-FFF2-40B4-BE49-F238E27FC236}">
-                    <a16:creationId xmlns:a16="http://schemas.microsoft.com/office/drawing/2014/main" xmlns="" id="{DD20092D-7FFA-4773-8A9A-F480B0C4CD44}"/>
+                    <a16:creationId xmlns:a16="http://schemas.microsoft.com/office/drawing/2014/main" id="{DD20092D-7FFA-4773-8A9A-F480B0C4CD44}"/>
                   </a:ext>
                 </a:extLst>
               </p:cNvPr>
@@ -33539,7 +33525,7 @@
                 <p:cNvPr id="55" name="Rectangle 54">
                   <a:extLst>
                     <a:ext uri="{FF2B5EF4-FFF2-40B4-BE49-F238E27FC236}">
-                      <a16:creationId xmlns:a16="http://schemas.microsoft.com/office/drawing/2014/main" xmlns="" id="{7EBE058D-DCEC-4FDE-A9D7-7042EB8DE7D5}"/>
+                      <a16:creationId xmlns:a16="http://schemas.microsoft.com/office/drawing/2014/main" id="{7EBE058D-DCEC-4FDE-A9D7-7042EB8DE7D5}"/>
                     </a:ext>
                   </a:extLst>
                 </p:cNvPr>
@@ -33591,7 +33577,7 @@
                 <p:cNvPr id="56" name="Rectangle: Folded Corner 55">
                   <a:extLst>
                     <a:ext uri="{FF2B5EF4-FFF2-40B4-BE49-F238E27FC236}">
-                      <a16:creationId xmlns:a16="http://schemas.microsoft.com/office/drawing/2014/main" xmlns="" id="{5B3D7597-F8E9-45FF-B411-DD5B9C7AE54A}"/>
+                      <a16:creationId xmlns:a16="http://schemas.microsoft.com/office/drawing/2014/main" id="{5B3D7597-F8E9-45FF-B411-DD5B9C7AE54A}"/>
                     </a:ext>
                   </a:extLst>
                 </p:cNvPr>
@@ -33647,7 +33633,7 @@
                 <p:cNvPr id="57" name="Rounded Rectangle 227">
                   <a:extLst>
                     <a:ext uri="{FF2B5EF4-FFF2-40B4-BE49-F238E27FC236}">
-                      <a16:creationId xmlns:a16="http://schemas.microsoft.com/office/drawing/2014/main" xmlns="" id="{D408C7A0-771E-4D47-AE8A-60906BF14BFD}"/>
+                      <a16:creationId xmlns:a16="http://schemas.microsoft.com/office/drawing/2014/main" id="{D408C7A0-771E-4D47-AE8A-60906BF14BFD}"/>
                     </a:ext>
                   </a:extLst>
                 </p:cNvPr>
@@ -33759,7 +33745,7 @@
               <p:cNvPr id="54" name="Rectangle 53">
                 <a:extLst>
                   <a:ext uri="{FF2B5EF4-FFF2-40B4-BE49-F238E27FC236}">
-                    <a16:creationId xmlns:a16="http://schemas.microsoft.com/office/drawing/2014/main" xmlns="" id="{02CD0C51-0925-40DB-8EC7-37B7F65FBA7A}"/>
+                    <a16:creationId xmlns:a16="http://schemas.microsoft.com/office/drawing/2014/main" id="{02CD0C51-0925-40DB-8EC7-37B7F65FBA7A}"/>
                   </a:ext>
                 </a:extLst>
               </p:cNvPr>
@@ -33811,7 +33797,7 @@
           <p:cNvPr id="15" name="Freeform 15">
             <a:extLst>
               <a:ext uri="{FF2B5EF4-FFF2-40B4-BE49-F238E27FC236}">
-                <a16:creationId xmlns:a16="http://schemas.microsoft.com/office/drawing/2014/main" xmlns="" id="{1F36BBAF-8E35-4BBD-93DA-CA86A3D26124}"/>
+                <a16:creationId xmlns:a16="http://schemas.microsoft.com/office/drawing/2014/main" id="{1F36BBAF-8E35-4BBD-93DA-CA86A3D26124}"/>
               </a:ext>
             </a:extLst>
           </p:cNvPr>
@@ -33906,7 +33892,7 @@
           <p:cNvPr id="16" name="Picture 3">
             <a:extLst>
               <a:ext uri="{FF2B5EF4-FFF2-40B4-BE49-F238E27FC236}">
-                <a16:creationId xmlns:a16="http://schemas.microsoft.com/office/drawing/2014/main" xmlns="" id="{CA27AC75-C45D-4D83-93A9-344803F88579}"/>
+                <a16:creationId xmlns:a16="http://schemas.microsoft.com/office/drawing/2014/main" id="{CA27AC75-C45D-4D83-93A9-344803F88579}"/>
               </a:ext>
             </a:extLst>
           </p:cNvPr>
@@ -34376,7 +34362,7 @@
           <p:cNvPr id="16" name="TextBox 15">
             <a:extLst>
               <a:ext uri="{FF2B5EF4-FFF2-40B4-BE49-F238E27FC236}">
-                <a16:creationId xmlns:a16="http://schemas.microsoft.com/office/drawing/2014/main" xmlns="" id="{A4319441-5814-459F-B6FC-CF71410ABE54}"/>
+                <a16:creationId xmlns:a16="http://schemas.microsoft.com/office/drawing/2014/main" id="{A4319441-5814-459F-B6FC-CF71410ABE54}"/>
               </a:ext>
             </a:extLst>
           </p:cNvPr>
@@ -34434,7 +34420,7 @@
           <p:cNvPr id="26" name="TextBox 25">
             <a:extLst>
               <a:ext uri="{FF2B5EF4-FFF2-40B4-BE49-F238E27FC236}">
-                <a16:creationId xmlns:a16="http://schemas.microsoft.com/office/drawing/2014/main" xmlns="" id="{0E45A66D-89AB-48D6-A592-2E049144F529}"/>
+                <a16:creationId xmlns:a16="http://schemas.microsoft.com/office/drawing/2014/main" id="{0E45A66D-89AB-48D6-A592-2E049144F529}"/>
               </a:ext>
             </a:extLst>
           </p:cNvPr>
@@ -34492,7 +34478,7 @@
           <p:cNvPr id="27" name="Picture 26">
             <a:extLst>
               <a:ext uri="{FF2B5EF4-FFF2-40B4-BE49-F238E27FC236}">
-                <a16:creationId xmlns:a16="http://schemas.microsoft.com/office/drawing/2014/main" xmlns="" id="{4471FF98-A804-43A6-9AD8-C8AA006706E9}"/>
+                <a16:creationId xmlns:a16="http://schemas.microsoft.com/office/drawing/2014/main" id="{4471FF98-A804-43A6-9AD8-C8AA006706E9}"/>
               </a:ext>
             </a:extLst>
           </p:cNvPr>
@@ -35064,7 +35050,7 @@
           <p:cNvPr id="11" name="TextBox 5">
             <a:extLst>
               <a:ext uri="{FF2B5EF4-FFF2-40B4-BE49-F238E27FC236}">
-                <a16:creationId xmlns:a16="http://schemas.microsoft.com/office/drawing/2014/main" xmlns="" id="{86B33BB2-9E4E-49D1-A38D-E85117C0712A}"/>
+                <a16:creationId xmlns:a16="http://schemas.microsoft.com/office/drawing/2014/main" id="{86B33BB2-9E4E-49D1-A38D-E85117C0712A}"/>
               </a:ext>
             </a:extLst>
           </p:cNvPr>
@@ -35175,7 +35161,7 @@
           <p:cNvPr id="7" name="Group 6">
             <a:extLst>
               <a:ext uri="{FF2B5EF4-FFF2-40B4-BE49-F238E27FC236}">
-                <a16:creationId xmlns:a16="http://schemas.microsoft.com/office/drawing/2014/main" xmlns="" id="{17CF63F4-3693-459F-93B5-26B2B6135EA8}"/>
+                <a16:creationId xmlns:a16="http://schemas.microsoft.com/office/drawing/2014/main" id="{17CF63F4-3693-459F-93B5-26B2B6135EA8}"/>
               </a:ext>
             </a:extLst>
           </p:cNvPr>
@@ -35195,7 +35181,7 @@
             <p:cNvPr id="8" name="Group 7">
               <a:extLst>
                 <a:ext uri="{FF2B5EF4-FFF2-40B4-BE49-F238E27FC236}">
-                  <a16:creationId xmlns:a16="http://schemas.microsoft.com/office/drawing/2014/main" xmlns="" id="{E8E3B2D8-756D-4306-AA79-A5839BC2293A}"/>
+                  <a16:creationId xmlns:a16="http://schemas.microsoft.com/office/drawing/2014/main" id="{E8E3B2D8-756D-4306-AA79-A5839BC2293A}"/>
                 </a:ext>
               </a:extLst>
             </p:cNvPr>
@@ -35215,7 +35201,7 @@
               <p:cNvPr id="10" name="Rectangle 9">
                 <a:extLst>
                   <a:ext uri="{FF2B5EF4-FFF2-40B4-BE49-F238E27FC236}">
-                    <a16:creationId xmlns:a16="http://schemas.microsoft.com/office/drawing/2014/main" xmlns="" id="{D117F593-662B-4427-A55E-2362ABC4D1A8}"/>
+                    <a16:creationId xmlns:a16="http://schemas.microsoft.com/office/drawing/2014/main" id="{D117F593-662B-4427-A55E-2362ABC4D1A8}"/>
                   </a:ext>
                 </a:extLst>
               </p:cNvPr>
@@ -35265,7 +35251,7 @@
               <p:cNvPr id="11" name="Rectangle 4">
                 <a:extLst>
                   <a:ext uri="{FF2B5EF4-FFF2-40B4-BE49-F238E27FC236}">
-                    <a16:creationId xmlns:a16="http://schemas.microsoft.com/office/drawing/2014/main" xmlns="" id="{6045FC6E-454C-471B-8C24-5040C73A43AE}"/>
+                    <a16:creationId xmlns:a16="http://schemas.microsoft.com/office/drawing/2014/main" id="{6045FC6E-454C-471B-8C24-5040C73A43AE}"/>
                   </a:ext>
                 </a:extLst>
               </p:cNvPr>
@@ -35365,7 +35351,7 @@
             <p:cNvPr id="9" name="Picture 8">
               <a:extLst>
                 <a:ext uri="{FF2B5EF4-FFF2-40B4-BE49-F238E27FC236}">
-                  <a16:creationId xmlns:a16="http://schemas.microsoft.com/office/drawing/2014/main" xmlns="" id="{32D1763D-61BB-449E-AC4C-B02F9B21C579}"/>
+                  <a16:creationId xmlns:a16="http://schemas.microsoft.com/office/drawing/2014/main" id="{32D1763D-61BB-449E-AC4C-B02F9B21C579}"/>
                 </a:ext>
               </a:extLst>
             </p:cNvPr>
@@ -36311,18 +36297,13 @@
             <a:p>
               <a:pPr algn="ctr"/>
               <a:r>
-                <a:rPr lang="en-SG" smtClean="0">
+                <a:rPr lang="en-SG">
                   <a:solidFill>
                     <a:srgbClr val="5A5A5A"/>
                   </a:solidFill>
                 </a:rPr>
                 <a:t>0</a:t>
               </a:r>
-              <a:endParaRPr lang="en-SG">
-                <a:solidFill>
-                  <a:srgbClr val="5A5A5A"/>
-                </a:solidFill>
-              </a:endParaRPr>
             </a:p>
           </p:txBody>
         </p:sp>
@@ -36384,18 +36365,13 @@
             <a:p>
               <a:pPr algn="ctr"/>
               <a:r>
-                <a:rPr lang="en-SG" smtClean="0">
+                <a:rPr lang="en-SG">
                   <a:solidFill>
                     <a:srgbClr val="5A5A5A"/>
                   </a:solidFill>
                 </a:rPr>
                 <a:t>10</a:t>
               </a:r>
-              <a:endParaRPr lang="en-SG">
-                <a:solidFill>
-                  <a:srgbClr val="5A5A5A"/>
-                </a:solidFill>
-              </a:endParaRPr>
             </a:p>
           </p:txBody>
         </p:sp>
@@ -36457,18 +36433,13 @@
             <a:p>
               <a:pPr algn="ctr"/>
               <a:r>
-                <a:rPr lang="en-SG" smtClean="0">
+                <a:rPr lang="en-SG">
                   <a:solidFill>
                     <a:srgbClr val="5A5A5A"/>
                   </a:solidFill>
                 </a:rPr>
                 <a:t>20</a:t>
               </a:r>
-              <a:endParaRPr lang="en-SG">
-                <a:solidFill>
-                  <a:srgbClr val="5A5A5A"/>
-                </a:solidFill>
-              </a:endParaRPr>
             </a:p>
           </p:txBody>
         </p:sp>
@@ -36530,18 +36501,13 @@
             <a:p>
               <a:pPr algn="ctr"/>
               <a:r>
-                <a:rPr lang="en-SG" smtClean="0">
+                <a:rPr lang="en-SG">
                   <a:solidFill>
                     <a:srgbClr val="5A5A5A"/>
                   </a:solidFill>
                 </a:rPr>
                 <a:t>30</a:t>
               </a:r>
-              <a:endParaRPr lang="en-SG">
-                <a:solidFill>
-                  <a:srgbClr val="5A5A5A"/>
-                </a:solidFill>
-              </a:endParaRPr>
             </a:p>
           </p:txBody>
         </p:sp>
@@ -36603,18 +36569,13 @@
             <a:p>
               <a:pPr algn="ctr"/>
               <a:r>
-                <a:rPr lang="en-SG" smtClean="0">
+                <a:rPr lang="en-SG">
                   <a:solidFill>
                     <a:srgbClr val="5A5A5A"/>
                   </a:solidFill>
                 </a:rPr>
                 <a:t>40</a:t>
               </a:r>
-              <a:endParaRPr lang="en-SG">
-                <a:solidFill>
-                  <a:srgbClr val="5A5A5A"/>
-                </a:solidFill>
-              </a:endParaRPr>
             </a:p>
           </p:txBody>
         </p:sp>
@@ -36676,18 +36637,13 @@
             <a:p>
               <a:pPr algn="ctr"/>
               <a:r>
-                <a:rPr lang="en-SG" smtClean="0">
+                <a:rPr lang="en-SG">
                   <a:solidFill>
                     <a:srgbClr val="5A5A5A"/>
                   </a:solidFill>
                 </a:rPr>
                 <a:t>50</a:t>
               </a:r>
-              <a:endParaRPr lang="en-SG">
-                <a:solidFill>
-                  <a:srgbClr val="5A5A5A"/>
-                </a:solidFill>
-              </a:endParaRPr>
             </a:p>
           </p:txBody>
         </p:sp>
@@ -36749,18 +36705,13 @@
             <a:p>
               <a:pPr algn="ctr"/>
               <a:r>
-                <a:rPr lang="en-SG" smtClean="0">
+                <a:rPr lang="en-SG">
                   <a:solidFill>
                     <a:srgbClr val="5A5A5A"/>
                   </a:solidFill>
                 </a:rPr>
                 <a:t>60</a:t>
               </a:r>
-              <a:endParaRPr lang="en-SG">
-                <a:solidFill>
-                  <a:srgbClr val="5A5A5A"/>
-                </a:solidFill>
-              </a:endParaRPr>
             </a:p>
           </p:txBody>
         </p:sp>
@@ -37035,7 +36986,7 @@
           <p:cNvPr id="16" name="Group 15">
             <a:extLst>
               <a:ext uri="{FF2B5EF4-FFF2-40B4-BE49-F238E27FC236}">
-                <a16:creationId xmlns:a16="http://schemas.microsoft.com/office/drawing/2014/main" xmlns="" id="{CD40D946-2D00-412C-82D9-E84C2252963E}"/>
+                <a16:creationId xmlns:a16="http://schemas.microsoft.com/office/drawing/2014/main" id="{CD40D946-2D00-412C-82D9-E84C2252963E}"/>
               </a:ext>
             </a:extLst>
           </p:cNvPr>
@@ -37055,7 +37006,7 @@
             <p:cNvPr id="20" name="Group 19">
               <a:extLst>
                 <a:ext uri="{FF2B5EF4-FFF2-40B4-BE49-F238E27FC236}">
-                  <a16:creationId xmlns:a16="http://schemas.microsoft.com/office/drawing/2014/main" xmlns="" id="{75CEDEA2-F53A-4C16-A788-5651EA86C318}"/>
+                  <a16:creationId xmlns:a16="http://schemas.microsoft.com/office/drawing/2014/main" id="{75CEDEA2-F53A-4C16-A788-5651EA86C318}"/>
                 </a:ext>
               </a:extLst>
             </p:cNvPr>
@@ -37075,7 +37026,7 @@
               <p:cNvPr id="23" name="Rectangle 22">
                 <a:extLst>
                   <a:ext uri="{FF2B5EF4-FFF2-40B4-BE49-F238E27FC236}">
-                    <a16:creationId xmlns:a16="http://schemas.microsoft.com/office/drawing/2014/main" xmlns="" id="{7F9DF475-A285-436F-A07B-15C766B2B8D5}"/>
+                    <a16:creationId xmlns:a16="http://schemas.microsoft.com/office/drawing/2014/main" id="{7F9DF475-A285-436F-A07B-15C766B2B8D5}"/>
                   </a:ext>
                 </a:extLst>
               </p:cNvPr>
@@ -37125,7 +37076,7 @@
               <p:cNvPr id="24" name="Rectangle 4">
                 <a:extLst>
                   <a:ext uri="{FF2B5EF4-FFF2-40B4-BE49-F238E27FC236}">
-                    <a16:creationId xmlns:a16="http://schemas.microsoft.com/office/drawing/2014/main" xmlns="" id="{23CB3783-79AA-4DA9-87FD-861C82E9BE19}"/>
+                    <a16:creationId xmlns:a16="http://schemas.microsoft.com/office/drawing/2014/main" id="{23CB3783-79AA-4DA9-87FD-861C82E9BE19}"/>
                   </a:ext>
                 </a:extLst>
               </p:cNvPr>
@@ -37225,7 +37176,7 @@
             <p:cNvPr id="21" name="Rectangle 20">
               <a:extLst>
                 <a:ext uri="{FF2B5EF4-FFF2-40B4-BE49-F238E27FC236}">
-                  <a16:creationId xmlns:a16="http://schemas.microsoft.com/office/drawing/2014/main" xmlns="" id="{C226511C-5D8E-4933-8CD8-1D4B9F55175C}"/>
+                  <a16:creationId xmlns:a16="http://schemas.microsoft.com/office/drawing/2014/main" id="{C226511C-5D8E-4933-8CD8-1D4B9F55175C}"/>
                 </a:ext>
               </a:extLst>
             </p:cNvPr>
@@ -37281,7 +37232,7 @@
             <p:cNvPr id="22" name="Rectangle 21">
               <a:extLst>
                 <a:ext uri="{FF2B5EF4-FFF2-40B4-BE49-F238E27FC236}">
-                  <a16:creationId xmlns:a16="http://schemas.microsoft.com/office/drawing/2014/main" xmlns="" id="{A01F586D-BDDF-4B5A-89DA-BB7E0BF3DE1B}"/>
+                  <a16:creationId xmlns:a16="http://schemas.microsoft.com/office/drawing/2014/main" id="{A01F586D-BDDF-4B5A-89DA-BB7E0BF3DE1B}"/>
                 </a:ext>
               </a:extLst>
             </p:cNvPr>
@@ -40602,16 +40553,6 @@
             </a:r>
           </a:p>
           <a:p>
-            <a:r>
-              <a:rPr lang="en-US" dirty="0">
-                <a:solidFill>
-                  <a:schemeClr val="accent6">
-                    <a:lumMod val="75000"/>
-                  </a:schemeClr>
-                </a:solidFill>
-              </a:rPr>
-              <a:t/>
-            </a:r>
             <a:br>
               <a:rPr lang="en-US" dirty="0">
                 <a:solidFill>
@@ -41679,6 +41620,186 @@
 </p:sld>
 </file>
 
+<file path=ppt/slides/slide68.xml><?xml version="1.0" encoding="utf-8"?>
+<p:sld xmlns:a="http://schemas.openxmlformats.org/drawingml/2006/main" xmlns:r="http://schemas.openxmlformats.org/officeDocument/2006/relationships" xmlns:p="http://schemas.openxmlformats.org/presentationml/2006/main">
+  <p:cSld>
+    <p:spTree>
+      <p:nvGrpSpPr>
+        <p:cNvPr id="1" name=""/>
+        <p:cNvGrpSpPr/>
+        <p:nvPr/>
+      </p:nvGrpSpPr>
+      <p:grpSpPr>
+        <a:xfrm>
+          <a:off x="0" y="0"/>
+          <a:ext cx="0" cy="0"/>
+          <a:chOff x="0" y="0"/>
+          <a:chExt cx="0" cy="0"/>
+        </a:xfrm>
+      </p:grpSpPr>
+      <p:sp>
+        <p:nvSpPr>
+          <p:cNvPr id="2" name="Title 1">
+            <a:extLst>
+              <a:ext uri="{FF2B5EF4-FFF2-40B4-BE49-F238E27FC236}">
+                <a16:creationId xmlns:a16="http://schemas.microsoft.com/office/drawing/2014/main" id="{49632FB0-1944-4BB0-16C2-C153CF229FA0}"/>
+              </a:ext>
+            </a:extLst>
+          </p:cNvPr>
+          <p:cNvSpPr>
+            <a:spLocks noGrp="1"/>
+          </p:cNvSpPr>
+          <p:nvPr>
+            <p:ph type="ctrTitle"/>
+          </p:nvPr>
+        </p:nvSpPr>
+        <p:spPr/>
+        <p:txBody>
+          <a:bodyPr/>
+          <a:lstStyle/>
+          <a:p>
+            <a:r>
+              <a:rPr lang="es-MX"/>
+              <a:t>BiomedPPTX Features</a:t>
+            </a:r>
+          </a:p>
+        </p:txBody>
+      </p:sp>
+      <p:sp>
+        <p:nvSpPr>
+          <p:cNvPr id="3" name="Subtitle 2">
+            <a:extLst>
+              <a:ext uri="{FF2B5EF4-FFF2-40B4-BE49-F238E27FC236}">
+                <a16:creationId xmlns:a16="http://schemas.microsoft.com/office/drawing/2014/main" id="{2582DE65-F100-4DA1-A227-0AD18A4511CB}"/>
+              </a:ext>
+            </a:extLst>
+          </p:cNvPr>
+          <p:cNvSpPr>
+            <a:spLocks noGrp="1"/>
+          </p:cNvSpPr>
+          <p:nvPr>
+            <p:ph type="subTitle" idx="1"/>
+          </p:nvPr>
+        </p:nvSpPr>
+        <p:spPr/>
+        <p:txBody>
+          <a:bodyPr/>
+          <a:lstStyle/>
+          <a:p>
+            <a:r>
+              <a:rPr lang="en-US"/>
+              <a:t>SMART Browser | Pattern Brush | Hue/Saturation Recolor</a:t>
+            </a:r>
+            <a:endParaRPr lang="es-MX"/>
+          </a:p>
+        </p:txBody>
+      </p:sp>
+    </p:spTree>
+    <p:extLst>
+      <p:ext uri="{BB962C8B-B14F-4D97-AF65-F5344CB8AC3E}">
+        <p14:creationId xmlns:p14="http://schemas.microsoft.com/office/powerpoint/2010/main" val="3817338630"/>
+      </p:ext>
+    </p:extLst>
+  </p:cSld>
+  <p:clrMapOvr>
+    <a:masterClrMapping/>
+  </p:clrMapOvr>
+</p:sld>
+</file>
+
+<file path=ppt/slides/slide69.xml><?xml version="1.0" encoding="utf-8"?>
+<p:sld xmlns:a="http://schemas.openxmlformats.org/drawingml/2006/main" xmlns:r="http://schemas.openxmlformats.org/officeDocument/2006/relationships" xmlns:p="http://schemas.openxmlformats.org/presentationml/2006/main">
+  <p:cSld>
+    <p:spTree>
+      <p:nvGrpSpPr>
+        <p:cNvPr id="1" name=""/>
+        <p:cNvGrpSpPr/>
+        <p:nvPr/>
+      </p:nvGrpSpPr>
+      <p:grpSpPr>
+        <a:xfrm>
+          <a:off x="0" y="0"/>
+          <a:ext cx="0" cy="0"/>
+          <a:chOff x="0" y="0"/>
+          <a:chExt cx="0" cy="0"/>
+        </a:xfrm>
+      </p:grpSpPr>
+      <p:sp>
+        <p:nvSpPr>
+          <p:cNvPr id="2" name="Title 1">
+            <a:extLst>
+              <a:ext uri="{FF2B5EF4-FFF2-40B4-BE49-F238E27FC236}">
+                <a16:creationId xmlns:a16="http://schemas.microsoft.com/office/drawing/2014/main" id="{3090F8A7-F76D-EE9C-D1F0-B6A92D22213A}"/>
+              </a:ext>
+            </a:extLst>
+          </p:cNvPr>
+          <p:cNvSpPr>
+            <a:spLocks noGrp="1"/>
+          </p:cNvSpPr>
+          <p:nvPr>
+            <p:ph type="title"/>
+          </p:nvPr>
+        </p:nvSpPr>
+        <p:spPr/>
+        <p:txBody>
+          <a:bodyPr/>
+          <a:lstStyle/>
+          <a:p>
+            <a:r>
+              <a:rPr lang="es-MX"/>
+              <a:t>SMART Browser</a:t>
+            </a:r>
+          </a:p>
+        </p:txBody>
+      </p:sp>
+      <p:sp>
+        <p:nvSpPr>
+          <p:cNvPr id="3" name="Text Placeholder 2">
+            <a:extLst>
+              <a:ext uri="{FF2B5EF4-FFF2-40B4-BE49-F238E27FC236}">
+                <a16:creationId xmlns:a16="http://schemas.microsoft.com/office/drawing/2014/main" id="{C442E2C8-9476-6782-AAF4-B2BD38721F50}"/>
+              </a:ext>
+            </a:extLst>
+          </p:cNvPr>
+          <p:cNvSpPr>
+            <a:spLocks noGrp="1"/>
+          </p:cNvSpPr>
+          <p:nvPr>
+            <p:ph type="body" idx="1"/>
+          </p:nvPr>
+        </p:nvSpPr>
+        <p:spPr/>
+        <p:txBody>
+          <a:bodyPr>
+            <a:normAutofit/>
+          </a:bodyPr>
+          <a:lstStyle/>
+          <a:p>
+            <a:r>
+              <a:rPr lang="es-MX" sz="1600"/>
+              <a:t>4,474 searchable biomedical illustrations
+49 categories: Cell membrane, Receptors, Blood, Nervous system...
+Full-text search by name, description, and topic
+Insert as editable grouped shape (primary) or SVG/PNG
+NCBI BioArt toggle: 661 additional online illustrations
+Right-click: Use as Path Pattern (1D) or Fill Pattern (2D)</a:t>
+            </a:r>
+          </a:p>
+        </p:txBody>
+      </p:sp>
+    </p:spTree>
+    <p:extLst>
+      <p:ext uri="{BB962C8B-B14F-4D97-AF65-F5344CB8AC3E}">
+        <p14:creationId xmlns:p14="http://schemas.microsoft.com/office/powerpoint/2010/main" val="2827973891"/>
+      </p:ext>
+    </p:extLst>
+  </p:cSld>
+  <p:clrMapOvr>
+    <a:masterClrMapping/>
+  </p:clrMapOvr>
+</p:sld>
+</file>
+
 <file path=ppt/slides/slide7.xml><?xml version="1.0" encoding="utf-8"?>
 <p:sld xmlns:a="http://schemas.openxmlformats.org/drawingml/2006/main" xmlns:r="http://schemas.openxmlformats.org/officeDocument/2006/relationships" xmlns:p="http://schemas.openxmlformats.org/presentationml/2006/main">
   <p:cSld name="PPSlideStart201402171123497521">
@@ -42170,6 +42291,567 @@
     <p:extLst>
       <p:ext uri="{BB962C8B-B14F-4D97-AF65-F5344CB8AC3E}">
         <p14:creationId xmlns:p14="http://schemas.microsoft.com/office/powerpoint/2010/main" val="3183536092"/>
+      </p:ext>
+    </p:extLst>
+  </p:cSld>
+  <p:clrMapOvr>
+    <a:masterClrMapping/>
+  </p:clrMapOvr>
+</p:sld>
+</file>
+
+<file path=ppt/slides/slide70.xml><?xml version="1.0" encoding="utf-8"?>
+<p:sld xmlns:a="http://schemas.openxmlformats.org/drawingml/2006/main" xmlns:r="http://schemas.openxmlformats.org/officeDocument/2006/relationships" xmlns:p="http://schemas.openxmlformats.org/presentationml/2006/main">
+  <p:cSld>
+    <p:spTree>
+      <p:nvGrpSpPr>
+        <p:cNvPr id="1" name=""/>
+        <p:cNvGrpSpPr/>
+        <p:nvPr/>
+      </p:nvGrpSpPr>
+      <p:grpSpPr>
+        <a:xfrm>
+          <a:off x="0" y="0"/>
+          <a:ext cx="0" cy="0"/>
+          <a:chOff x="0" y="0"/>
+          <a:chExt cx="0" cy="0"/>
+        </a:xfrm>
+      </p:grpSpPr>
+      <p:sp>
+        <p:nvSpPr>
+          <p:cNvPr id="2" name="Title 1">
+            <a:extLst>
+              <a:ext uri="{FF2B5EF4-FFF2-40B4-BE49-F238E27FC236}">
+                <a16:creationId xmlns:a16="http://schemas.microsoft.com/office/drawing/2014/main" id="{D48DD7ED-FD57-9A3B-1EA1-3E208F947065}"/>
+              </a:ext>
+            </a:extLst>
+          </p:cNvPr>
+          <p:cNvSpPr>
+            <a:spLocks noGrp="1"/>
+          </p:cNvSpPr>
+          <p:nvPr>
+            <p:ph type="title"/>
+          </p:nvPr>
+        </p:nvSpPr>
+        <p:spPr/>
+        <p:txBody>
+          <a:bodyPr/>
+          <a:lstStyle/>
+          <a:p>
+            <a:r>
+              <a:rPr lang="es-MX"/>
+              <a:t>Using SMART Browser</a:t>
+            </a:r>
+          </a:p>
+        </p:txBody>
+      </p:sp>
+      <p:sp>
+        <p:nvSpPr>
+          <p:cNvPr id="3" name="Text Placeholder 2">
+            <a:extLst>
+              <a:ext uri="{FF2B5EF4-FFF2-40B4-BE49-F238E27FC236}">
+                <a16:creationId xmlns:a16="http://schemas.microsoft.com/office/drawing/2014/main" id="{FF8394ED-6F7E-8ECB-FBBA-8A6AD3308FB5}"/>
+              </a:ext>
+            </a:extLst>
+          </p:cNvPr>
+          <p:cNvSpPr>
+            <a:spLocks noGrp="1"/>
+          </p:cNvSpPr>
+          <p:nvPr>
+            <p:ph type="body" idx="1"/>
+          </p:nvPr>
+        </p:nvSpPr>
+        <p:spPr/>
+        <p:txBody>
+          <a:bodyPr>
+            <a:normAutofit/>
+          </a:bodyPr>
+          <a:lstStyle/>
+          <a:p>
+            <a:r>
+              <a:rPr lang="es-MX" sz="1600"/>
+              <a:t>1. Click 'SMART Browser' in the BiomedPPTX ribbon tab
+2. Search by typing keywords (e.g., 'phospholipid', 'neuron')
+3. Filter by category or tag (standalone, membrane-component...)
+4. Double-click an illustration to insert it on the slide
+5. Right-click for options: Insert Editable, Insert Image, Use as Pattern
+6. Toggle 'BioArt' checkbox to search NCBI online illustrations</a:t>
+            </a:r>
+          </a:p>
+        </p:txBody>
+      </p:sp>
+    </p:spTree>
+    <p:extLst>
+      <p:ext uri="{BB962C8B-B14F-4D97-AF65-F5344CB8AC3E}">
+        <p14:creationId xmlns:p14="http://schemas.microsoft.com/office/powerpoint/2010/main" val="1825036996"/>
+      </p:ext>
+    </p:extLst>
+  </p:cSld>
+  <p:clrMapOvr>
+    <a:masterClrMapping/>
+  </p:clrMapOvr>
+</p:sld>
+</file>
+
+<file path=ppt/slides/slide71.xml><?xml version="1.0" encoding="utf-8"?>
+<p:sld xmlns:a="http://schemas.openxmlformats.org/drawingml/2006/main" xmlns:r="http://schemas.openxmlformats.org/officeDocument/2006/relationships" xmlns:p="http://schemas.openxmlformats.org/presentationml/2006/main">
+  <p:cSld>
+    <p:spTree>
+      <p:nvGrpSpPr>
+        <p:cNvPr id="1" name=""/>
+        <p:cNvGrpSpPr/>
+        <p:nvPr/>
+      </p:nvGrpSpPr>
+      <p:grpSpPr>
+        <a:xfrm>
+          <a:off x="0" y="0"/>
+          <a:ext cx="0" cy="0"/>
+          <a:chOff x="0" y="0"/>
+          <a:chExt cx="0" cy="0"/>
+        </a:xfrm>
+      </p:grpSpPr>
+      <p:sp>
+        <p:nvSpPr>
+          <p:cNvPr id="2" name="Title 1">
+            <a:extLst>
+              <a:ext uri="{FF2B5EF4-FFF2-40B4-BE49-F238E27FC236}">
+                <a16:creationId xmlns:a16="http://schemas.microsoft.com/office/drawing/2014/main" id="{105B3A45-4D48-F2F5-4529-46F96C27C5BC}"/>
+              </a:ext>
+            </a:extLst>
+          </p:cNvPr>
+          <p:cNvSpPr>
+            <a:spLocks noGrp="1"/>
+          </p:cNvSpPr>
+          <p:nvPr>
+            <p:ph type="title"/>
+          </p:nvPr>
+        </p:nvSpPr>
+        <p:spPr/>
+        <p:txBody>
+          <a:bodyPr/>
+          <a:lstStyle/>
+          <a:p>
+            <a:r>
+              <a:rPr lang="es-MX"/>
+              <a:t>Pattern Brush</a:t>
+            </a:r>
+          </a:p>
+        </p:txBody>
+      </p:sp>
+      <p:sp>
+        <p:nvSpPr>
+          <p:cNvPr id="3" name="Text Placeholder 2">
+            <a:extLst>
+              <a:ext uri="{FF2B5EF4-FFF2-40B4-BE49-F238E27FC236}">
+                <a16:creationId xmlns:a16="http://schemas.microsoft.com/office/drawing/2014/main" id="{F94CA707-92F5-2554-AA79-07955D34D4D5}"/>
+              </a:ext>
+            </a:extLst>
+          </p:cNvPr>
+          <p:cNvSpPr>
+            <a:spLocks noGrp="1"/>
+          </p:cNvSpPr>
+          <p:nvPr>
+            <p:ph type="body" idx="1"/>
+          </p:nvPr>
+        </p:nvSpPr>
+        <p:spPr/>
+        <p:txBody>
+          <a:bodyPr>
+            <a:normAutofit/>
+          </a:bodyPr>
+          <a:lstStyle/>
+          <a:p>
+            <a:r>
+              <a:rPr lang="es-MX" sz="1600"/>
+              <a:t>238 tileable biological patterns + custom patterns
+1D tiling: along lines, freeforms, and shape outlines
+2D tiling: grid fill with brick pattern offset
+Supports circles, triangles, stars, hexagons, polygons
+Controls: Offset X/Y, Angle, Scatter, Jitter
+Mode selector: Auto / Along Outline / Fill Area</a:t>
+            </a:r>
+          </a:p>
+        </p:txBody>
+      </p:sp>
+    </p:spTree>
+    <p:extLst>
+      <p:ext uri="{BB962C8B-B14F-4D97-AF65-F5344CB8AC3E}">
+        <p14:creationId xmlns:p14="http://schemas.microsoft.com/office/powerpoint/2010/main" val="3855576783"/>
+      </p:ext>
+    </p:extLst>
+  </p:cSld>
+  <p:clrMapOvr>
+    <a:masterClrMapping/>
+  </p:clrMapOvr>
+</p:sld>
+</file>
+
+<file path=ppt/slides/slide72.xml><?xml version="1.0" encoding="utf-8"?>
+<p:sld xmlns:a="http://schemas.openxmlformats.org/drawingml/2006/main" xmlns:r="http://schemas.openxmlformats.org/officeDocument/2006/relationships" xmlns:p="http://schemas.openxmlformats.org/presentationml/2006/main">
+  <p:cSld>
+    <p:spTree>
+      <p:nvGrpSpPr>
+        <p:cNvPr id="1" name=""/>
+        <p:cNvGrpSpPr/>
+        <p:nvPr/>
+      </p:nvGrpSpPr>
+      <p:grpSpPr>
+        <a:xfrm>
+          <a:off x="0" y="0"/>
+          <a:ext cx="0" cy="0"/>
+          <a:chOff x="0" y="0"/>
+          <a:chExt cx="0" cy="0"/>
+        </a:xfrm>
+      </p:grpSpPr>
+      <p:sp>
+        <p:nvSpPr>
+          <p:cNvPr id="2" name="Title 1">
+            <a:extLst>
+              <a:ext uri="{FF2B5EF4-FFF2-40B4-BE49-F238E27FC236}">
+                <a16:creationId xmlns:a16="http://schemas.microsoft.com/office/drawing/2014/main" id="{118A41CB-5AE0-567D-C495-3D51C2DA7127}"/>
+              </a:ext>
+            </a:extLst>
+          </p:cNvPr>
+          <p:cNvSpPr>
+            <a:spLocks noGrp="1"/>
+          </p:cNvSpPr>
+          <p:nvPr>
+            <p:ph type="title"/>
+          </p:nvPr>
+        </p:nvSpPr>
+        <p:spPr/>
+        <p:txBody>
+          <a:bodyPr/>
+          <a:lstStyle/>
+          <a:p>
+            <a:r>
+              <a:rPr lang="es-MX"/>
+              <a:t>Using Pattern Brush</a:t>
+            </a:r>
+          </a:p>
+        </p:txBody>
+      </p:sp>
+      <p:sp>
+        <p:nvSpPr>
+          <p:cNvPr id="3" name="Text Placeholder 2">
+            <a:extLst>
+              <a:ext uri="{FF2B5EF4-FFF2-40B4-BE49-F238E27FC236}">
+                <a16:creationId xmlns:a16="http://schemas.microsoft.com/office/drawing/2014/main" id="{5AA206BC-8A75-ADA1-84C8-0C3203355D5F}"/>
+              </a:ext>
+            </a:extLst>
+          </p:cNvPr>
+          <p:cNvSpPr>
+            <a:spLocks noGrp="1"/>
+          </p:cNvSpPr>
+          <p:nvPr>
+            <p:ph type="body" idx="1"/>
+          </p:nvPr>
+        </p:nvSpPr>
+        <p:spPr/>
+        <p:txBody>
+          <a:bodyPr>
+            <a:normAutofit/>
+          </a:bodyPr>
+          <a:lstStyle/>
+          <a:p>
+            <a:r>
+              <a:rPr lang="en-US" sz="1600"/>
+              <a:t>1. Click 'Pattern Brush' in the BiomedPPTX ribbon tab
+2. Select a tileable pattern from the grid
+3. Draw or select a line/freeform/shape on the slide
+4. Adjust Offset, Angle, Scatter, Jitter as needed
+5. Click 'Apply to Selection' to tile the pattern
+6. Use 'Draw' button to create a quick guide line
+7. Set Mode to 'Along Outline' for shapes like circles/stars</a:t>
+            </a:r>
+            <a:endParaRPr lang="es-MX" sz="1600"/>
+          </a:p>
+        </p:txBody>
+      </p:sp>
+    </p:spTree>
+    <p:extLst>
+      <p:ext uri="{BB962C8B-B14F-4D97-AF65-F5344CB8AC3E}">
+        <p14:creationId xmlns:p14="http://schemas.microsoft.com/office/powerpoint/2010/main" val="4205166599"/>
+      </p:ext>
+    </p:extLst>
+  </p:cSld>
+  <p:clrMapOvr>
+    <a:masterClrMapping/>
+  </p:clrMapOvr>
+</p:sld>
+</file>
+
+<file path=ppt/slides/slide73.xml><?xml version="1.0" encoding="utf-8"?>
+<p:sld xmlns:a="http://schemas.openxmlformats.org/drawingml/2006/main" xmlns:r="http://schemas.openxmlformats.org/officeDocument/2006/relationships" xmlns:p="http://schemas.openxmlformats.org/presentationml/2006/main">
+  <p:cSld>
+    <p:spTree>
+      <p:nvGrpSpPr>
+        <p:cNvPr id="1" name=""/>
+        <p:cNvGrpSpPr/>
+        <p:nvPr/>
+      </p:nvGrpSpPr>
+      <p:grpSpPr>
+        <a:xfrm>
+          <a:off x="0" y="0"/>
+          <a:ext cx="0" cy="0"/>
+          <a:chOff x="0" y="0"/>
+          <a:chExt cx="0" cy="0"/>
+        </a:xfrm>
+      </p:grpSpPr>
+      <p:sp>
+        <p:nvSpPr>
+          <p:cNvPr id="2" name="Title 1">
+            <a:extLst>
+              <a:ext uri="{FF2B5EF4-FFF2-40B4-BE49-F238E27FC236}">
+                <a16:creationId xmlns:a16="http://schemas.microsoft.com/office/drawing/2014/main" id="{359F014D-C741-01CF-68D7-E35560B0F90A}"/>
+              </a:ext>
+            </a:extLst>
+          </p:cNvPr>
+          <p:cNvSpPr>
+            <a:spLocks noGrp="1"/>
+          </p:cNvSpPr>
+          <p:nvPr>
+            <p:ph type="title"/>
+          </p:nvPr>
+        </p:nvSpPr>
+        <p:spPr/>
+        <p:txBody>
+          <a:bodyPr/>
+          <a:lstStyle/>
+          <a:p>
+            <a:r>
+              <a:rPr lang="es-MX"/>
+              <a:t>Pattern Brush Tips</a:t>
+            </a:r>
+          </a:p>
+        </p:txBody>
+      </p:sp>
+      <p:sp>
+        <p:nvSpPr>
+          <p:cNvPr id="3" name="Text Placeholder 2">
+            <a:extLst>
+              <a:ext uri="{FF2B5EF4-FFF2-40B4-BE49-F238E27FC236}">
+                <a16:creationId xmlns:a16="http://schemas.microsoft.com/office/drawing/2014/main" id="{68A74B3F-990C-C216-3437-9E8BECF04083}"/>
+              </a:ext>
+            </a:extLst>
+          </p:cNvPr>
+          <p:cNvSpPr>
+            <a:spLocks noGrp="1"/>
+          </p:cNvSpPr>
+          <p:nvPr>
+            <p:ph type="body" idx="1"/>
+          </p:nvPr>
+        </p:nvSpPr>
+        <p:spPr/>
+        <p:txBody>
+          <a:bodyPr>
+            <a:normAutofit/>
+          </a:bodyPr>
+          <a:lstStyle/>
+          <a:p>
+            <a:r>
+              <a:rPr lang="es-MX" sz="1600"/>
+              <a:t>Negative Offset X: tiles overlap (tighter, e.g., -10 for membranes)
+Angle = -90: perpendicular orientation (phospholipid heads outward)
+Scatter + Jitter: natural look for cells in blood vessels
+Any SMART illustration can be a pattern (right-click &gt; Use as Pattern)
+2D patterns use brick offset for epithelial tissue layers
+All tiled shapes are grouped and can be ungrouped for editing</a:t>
+            </a:r>
+          </a:p>
+        </p:txBody>
+      </p:sp>
+    </p:spTree>
+    <p:extLst>
+      <p:ext uri="{BB962C8B-B14F-4D97-AF65-F5344CB8AC3E}">
+        <p14:creationId xmlns:p14="http://schemas.microsoft.com/office/powerpoint/2010/main" val="438982556"/>
+      </p:ext>
+    </p:extLst>
+  </p:cSld>
+  <p:clrMapOvr>
+    <a:masterClrMapping/>
+  </p:clrMapOvr>
+</p:sld>
+</file>
+
+<file path=ppt/slides/slide74.xml><?xml version="1.0" encoding="utf-8"?>
+<p:sld xmlns:a="http://schemas.openxmlformats.org/drawingml/2006/main" xmlns:r="http://schemas.openxmlformats.org/officeDocument/2006/relationships" xmlns:p="http://schemas.openxmlformats.org/presentationml/2006/main">
+  <p:cSld>
+    <p:spTree>
+      <p:nvGrpSpPr>
+        <p:cNvPr id="1" name=""/>
+        <p:cNvGrpSpPr/>
+        <p:nvPr/>
+      </p:nvGrpSpPr>
+      <p:grpSpPr>
+        <a:xfrm>
+          <a:off x="0" y="0"/>
+          <a:ext cx="0" cy="0"/>
+          <a:chOff x="0" y="0"/>
+          <a:chExt cx="0" cy="0"/>
+        </a:xfrm>
+      </p:grpSpPr>
+      <p:sp>
+        <p:nvSpPr>
+          <p:cNvPr id="2" name="Title 1">
+            <a:extLst>
+              <a:ext uri="{FF2B5EF4-FFF2-40B4-BE49-F238E27FC236}">
+                <a16:creationId xmlns:a16="http://schemas.microsoft.com/office/drawing/2014/main" id="{441F5471-C688-4C76-CEE5-11C8E1E2675A}"/>
+              </a:ext>
+            </a:extLst>
+          </p:cNvPr>
+          <p:cNvSpPr>
+            <a:spLocks noGrp="1"/>
+          </p:cNvSpPr>
+          <p:nvPr>
+            <p:ph type="title"/>
+          </p:nvPr>
+        </p:nvSpPr>
+        <p:spPr/>
+        <p:txBody>
+          <a:bodyPr/>
+          <a:lstStyle/>
+          <a:p>
+            <a:r>
+              <a:rPr lang="es-MX"/>
+              <a:t>Hue/Saturation Recolor</a:t>
+            </a:r>
+          </a:p>
+        </p:txBody>
+      </p:sp>
+      <p:sp>
+        <p:nvSpPr>
+          <p:cNvPr id="3" name="Text Placeholder 2">
+            <a:extLst>
+              <a:ext uri="{FF2B5EF4-FFF2-40B4-BE49-F238E27FC236}">
+                <a16:creationId xmlns:a16="http://schemas.microsoft.com/office/drawing/2014/main" id="{BCFBD948-75CB-7977-C317-01AA88327369}"/>
+              </a:ext>
+            </a:extLst>
+          </p:cNvPr>
+          <p:cNvSpPr>
+            <a:spLocks noGrp="1"/>
+          </p:cNvSpPr>
+          <p:nvPr>
+            <p:ph type="body" idx="1"/>
+          </p:nvPr>
+        </p:nvSpPr>
+        <p:spPr/>
+        <p:txBody>
+          <a:bodyPr>
+            <a:normAutofit/>
+          </a:bodyPr>
+          <a:lstStyle/>
+          <a:p>
+            <a:r>
+              <a:rPr lang="en-US" sz="1600"/>
+              <a:t>Adjust colors of inserted SMART-Library grouped shapes
+Click 'Recolor' toggle in SMART Browser to show sliders
+Hue Shift (-180 to +180): rotates all colors around the wheel
+Saturation (0-200%): controls color intensity
+Whites, blacks, and grays are preserved (not affected)
+Works on grouped shapes and tiled patterns, not on images</a:t>
+            </a:r>
+            <a:endParaRPr lang="es-MX" sz="1600"/>
+          </a:p>
+        </p:txBody>
+      </p:sp>
+    </p:spTree>
+    <p:extLst>
+      <p:ext uri="{BB962C8B-B14F-4D97-AF65-F5344CB8AC3E}">
+        <p14:creationId xmlns:p14="http://schemas.microsoft.com/office/powerpoint/2010/main" val="2881039565"/>
+      </p:ext>
+    </p:extLst>
+  </p:cSld>
+  <p:clrMapOvr>
+    <a:masterClrMapping/>
+  </p:clrMapOvr>
+</p:sld>
+</file>
+
+<file path=ppt/slides/slide75.xml><?xml version="1.0" encoding="utf-8"?>
+<p:sld xmlns:a="http://schemas.openxmlformats.org/drawingml/2006/main" xmlns:r="http://schemas.openxmlformats.org/officeDocument/2006/relationships" xmlns:p="http://schemas.openxmlformats.org/presentationml/2006/main">
+  <p:cSld>
+    <p:spTree>
+      <p:nvGrpSpPr>
+        <p:cNvPr id="1" name=""/>
+        <p:cNvGrpSpPr/>
+        <p:nvPr/>
+      </p:nvGrpSpPr>
+      <p:grpSpPr>
+        <a:xfrm>
+          <a:off x="0" y="0"/>
+          <a:ext cx="0" cy="0"/>
+          <a:chOff x="0" y="0"/>
+          <a:chExt cx="0" cy="0"/>
+        </a:xfrm>
+      </p:grpSpPr>
+      <p:sp>
+        <p:nvSpPr>
+          <p:cNvPr id="2" name="Title 1">
+            <a:extLst>
+              <a:ext uri="{FF2B5EF4-FFF2-40B4-BE49-F238E27FC236}">
+                <a16:creationId xmlns:a16="http://schemas.microsoft.com/office/drawing/2014/main" id="{C936809E-6CBF-15D6-7E70-125E55875F98}"/>
+              </a:ext>
+            </a:extLst>
+          </p:cNvPr>
+          <p:cNvSpPr>
+            <a:spLocks noGrp="1"/>
+          </p:cNvSpPr>
+          <p:nvPr>
+            <p:ph type="title"/>
+          </p:nvPr>
+        </p:nvSpPr>
+        <p:spPr/>
+        <p:txBody>
+          <a:bodyPr/>
+          <a:lstStyle/>
+          <a:p>
+            <a:r>
+              <a:rPr lang="es-MX"/>
+              <a:t>Licensing &amp; Attribution</a:t>
+            </a:r>
+          </a:p>
+        </p:txBody>
+      </p:sp>
+      <p:sp>
+        <p:nvSpPr>
+          <p:cNvPr id="3" name="Text Placeholder 2">
+            <a:extLst>
+              <a:ext uri="{FF2B5EF4-FFF2-40B4-BE49-F238E27FC236}">
+                <a16:creationId xmlns:a16="http://schemas.microsoft.com/office/drawing/2014/main" id="{720A1765-4FCC-29DA-090A-065B5C0834A5}"/>
+              </a:ext>
+            </a:extLst>
+          </p:cNvPr>
+          <p:cNvSpPr>
+            <a:spLocks noGrp="1"/>
+          </p:cNvSpPr>
+          <p:nvPr>
+            <p:ph type="body" idx="1"/>
+          </p:nvPr>
+        </p:nvSpPr>
+        <p:spPr/>
+        <p:txBody>
+          <a:bodyPr>
+            <a:normAutofit/>
+          </a:bodyPr>
+          <a:lstStyle/>
+          <a:p>
+            <a:r>
+              <a:rPr lang="es-MX" sz="1600"/>
+              <a:t>BiomedPPTX: GPLv2 (same as PowerPointLabs)
+SMART Illustrations: CC BY 3.0 - Servier Medical ART
+  Attribution required when publishing
+NCBI BioArt: Public Domain / CC-BY (NIAID)
+Help &gt; Licensing: view all licenses and copy attribution
+Help &gt; Licensing &gt; Add Attribution Slide: auto-generate</a:t>
+            </a:r>
+          </a:p>
+        </p:txBody>
+      </p:sp>
+    </p:spTree>
+    <p:extLst>
+      <p:ext uri="{BB962C8B-B14F-4D97-AF65-F5344CB8AC3E}">
+        <p14:creationId xmlns:p14="http://schemas.microsoft.com/office/powerpoint/2010/main" val="430157605"/>
       </p:ext>
     </p:extLst>
   </p:cSld>
@@ -42579,7 +43261,7 @@
             <p:cNvPr id="18" name="Group 17">
               <a:extLst>
                 <a:ext uri="{FF2B5EF4-FFF2-40B4-BE49-F238E27FC236}">
-                  <a16:creationId xmlns:a16="http://schemas.microsoft.com/office/drawing/2014/main" xmlns="" id="{50FC66A1-77B5-45B7-8889-AB9F65F3C36E}"/>
+                  <a16:creationId xmlns:a16="http://schemas.microsoft.com/office/drawing/2014/main" id="{50FC66A1-77B5-45B7-8889-AB9F65F3C36E}"/>
                 </a:ext>
               </a:extLst>
             </p:cNvPr>
@@ -42797,7 +43479,7 @@
               <p:cNvPr id="22" name="Group 21">
                 <a:extLst>
                   <a:ext uri="{FF2B5EF4-FFF2-40B4-BE49-F238E27FC236}">
-                    <a16:creationId xmlns:a16="http://schemas.microsoft.com/office/drawing/2014/main" xmlns="" id="{F5D78658-F6C6-46B3-8E89-3147C3306144}"/>
+                    <a16:creationId xmlns:a16="http://schemas.microsoft.com/office/drawing/2014/main" id="{F5D78658-F6C6-46B3-8E89-3147C3306144}"/>
                   </a:ext>
                 </a:extLst>
               </p:cNvPr>
@@ -42817,7 +43499,7 @@
                 <p:cNvPr id="23" name="Rectangular Callout 6">
                   <a:extLst>
                     <a:ext uri="{FF2B5EF4-FFF2-40B4-BE49-F238E27FC236}">
-                      <a16:creationId xmlns:a16="http://schemas.microsoft.com/office/drawing/2014/main" xmlns="" id="{1FC8639D-28D2-4B1A-B64F-48D215B62821}"/>
+                      <a16:creationId xmlns:a16="http://schemas.microsoft.com/office/drawing/2014/main" id="{1FC8639D-28D2-4B1A-B64F-48D215B62821}"/>
                     </a:ext>
                   </a:extLst>
                 </p:cNvPr>
@@ -42872,7 +43554,7 @@
                 <p:cNvPr id="24" name="Straight Connector 23">
                   <a:extLst>
                     <a:ext uri="{FF2B5EF4-FFF2-40B4-BE49-F238E27FC236}">
-                      <a16:creationId xmlns:a16="http://schemas.microsoft.com/office/drawing/2014/main" xmlns="" id="{7BB3C0C0-A39F-42D6-B1EC-3DFB03D81DA6}"/>
+                      <a16:creationId xmlns:a16="http://schemas.microsoft.com/office/drawing/2014/main" id="{7BB3C0C0-A39F-42D6-B1EC-3DFB03D81DA6}"/>
                     </a:ext>
                   </a:extLst>
                 </p:cNvPr>
@@ -42915,7 +43597,7 @@
                 <p:cNvPr id="25" name="Straight Connector 24">
                   <a:extLst>
                     <a:ext uri="{FF2B5EF4-FFF2-40B4-BE49-F238E27FC236}">
-                      <a16:creationId xmlns:a16="http://schemas.microsoft.com/office/drawing/2014/main" xmlns="" id="{3F9239F3-B320-479E-9E88-B5EE0FFE7EDD}"/>
+                      <a16:creationId xmlns:a16="http://schemas.microsoft.com/office/drawing/2014/main" id="{3F9239F3-B320-479E-9E88-B5EE0FFE7EDD}"/>
                     </a:ext>
                   </a:extLst>
                 </p:cNvPr>
@@ -42958,7 +43640,7 @@
                 <p:cNvPr id="26" name="Straight Connector 25">
                   <a:extLst>
                     <a:ext uri="{FF2B5EF4-FFF2-40B4-BE49-F238E27FC236}">
-                      <a16:creationId xmlns:a16="http://schemas.microsoft.com/office/drawing/2014/main" xmlns="" id="{060AE25F-756D-4BC6-B66E-9297FD09E6E6}"/>
+                      <a16:creationId xmlns:a16="http://schemas.microsoft.com/office/drawing/2014/main" id="{060AE25F-756D-4BC6-B66E-9297FD09E6E6}"/>
                     </a:ext>
                   </a:extLst>
                 </p:cNvPr>
@@ -43003,7 +43685,7 @@
             <p:cNvPr id="19" name="Straight Connector 18">
               <a:extLst>
                 <a:ext uri="{FF2B5EF4-FFF2-40B4-BE49-F238E27FC236}">
-                  <a16:creationId xmlns:a16="http://schemas.microsoft.com/office/drawing/2014/main" xmlns="" id="{49614C63-4EB0-43CA-853C-D98FF90EBB5D}"/>
+                  <a16:creationId xmlns:a16="http://schemas.microsoft.com/office/drawing/2014/main" id="{49614C63-4EB0-43CA-853C-D98FF90EBB5D}"/>
                 </a:ext>
               </a:extLst>
             </p:cNvPr>

</xml_diff>